<commit_message>
docs: update link demo video
</commit_message>
<xml_diff>
--- a/docs/seminar_slide.pptx
+++ b/docs/seminar_slide.pptx
@@ -2,27 +2,27 @@
 <file path=ppt/presentation.xml><?xml version="1.0" encoding="utf-8"?>
 <p:presentation xmlns:p="http://schemas.openxmlformats.org/presentationml/2006/main">
   <p:sldMasterIdLst>
-    <p:sldMasterId xmlns:r="http://schemas.openxmlformats.org/officeDocument/2006/relationships" id="2147483648" r:id="Raf6647aeb7bb4395"/>
+    <p:sldMasterId xmlns:r="http://schemas.openxmlformats.org/officeDocument/2006/relationships" id="2147483648" r:id="Reed8e27a37324909"/>
   </p:sldMasterIdLst>
   <p:notesMasterIdLst>
-    <p:notesMasterId xmlns:r="http://schemas.openxmlformats.org/officeDocument/2006/relationships" r:id="R7bf2be65133b4d88"/>
+    <p:notesMasterId xmlns:r="http://schemas.openxmlformats.org/officeDocument/2006/relationships" r:id="Ra9836ee65e714077"/>
   </p:notesMasterIdLst>
   <p:sldIdLst>
-    <p:sldId xmlns:r="http://schemas.openxmlformats.org/officeDocument/2006/relationships" id="256" r:id="Ra56d13ea53014c47"/>
-    <p:sldId xmlns:r="http://schemas.openxmlformats.org/officeDocument/2006/relationships" id="257" r:id="R78280be2899345e0"/>
-    <p:sldId xmlns:r="http://schemas.openxmlformats.org/officeDocument/2006/relationships" id="258" r:id="R79edde240d7d4c91"/>
-    <p:sldId xmlns:r="http://schemas.openxmlformats.org/officeDocument/2006/relationships" id="259" r:id="R91e9dce297964108"/>
-    <p:sldId xmlns:r="http://schemas.openxmlformats.org/officeDocument/2006/relationships" id="260" r:id="Re72ffbd4bdfd4c57"/>
-    <p:sldId xmlns:r="http://schemas.openxmlformats.org/officeDocument/2006/relationships" id="261" r:id="Ra0978ebef5e54585"/>
-    <p:sldId xmlns:r="http://schemas.openxmlformats.org/officeDocument/2006/relationships" id="262" r:id="R5cf0cb2098f243a6"/>
-    <p:sldId xmlns:r="http://schemas.openxmlformats.org/officeDocument/2006/relationships" id="263" r:id="Rbdf931893752419b"/>
-    <p:sldId xmlns:r="http://schemas.openxmlformats.org/officeDocument/2006/relationships" id="264" r:id="Rcbeb9df2cacc4846"/>
-    <p:sldId xmlns:r="http://schemas.openxmlformats.org/officeDocument/2006/relationships" id="265" r:id="R99198f02ab2f401b"/>
-    <p:sldId xmlns:r="http://schemas.openxmlformats.org/officeDocument/2006/relationships" id="266" r:id="Rcfef46e5b7df480c"/>
-    <p:sldId xmlns:r="http://schemas.openxmlformats.org/officeDocument/2006/relationships" id="267" r:id="R6fb82ceb9aae44dd"/>
-    <p:sldId xmlns:r="http://schemas.openxmlformats.org/officeDocument/2006/relationships" id="268" r:id="R0d27dd1525104cab"/>
-    <p:sldId xmlns:r="http://schemas.openxmlformats.org/officeDocument/2006/relationships" id="269" r:id="Rc17ab9dab53d4694"/>
-    <p:sldId xmlns:r="http://schemas.openxmlformats.org/officeDocument/2006/relationships" id="270" r:id="Rcbc212af397c4b8b"/>
+    <p:sldId xmlns:r="http://schemas.openxmlformats.org/officeDocument/2006/relationships" id="256" r:id="Rf406045e9a57477b"/>
+    <p:sldId xmlns:r="http://schemas.openxmlformats.org/officeDocument/2006/relationships" id="257" r:id="R5b237cf84f3f439d"/>
+    <p:sldId xmlns:r="http://schemas.openxmlformats.org/officeDocument/2006/relationships" id="258" r:id="Rbb25253d14034303"/>
+    <p:sldId xmlns:r="http://schemas.openxmlformats.org/officeDocument/2006/relationships" id="259" r:id="Rda4ea7cc26394a52"/>
+    <p:sldId xmlns:r="http://schemas.openxmlformats.org/officeDocument/2006/relationships" id="260" r:id="R80d581c4cb4446d2"/>
+    <p:sldId xmlns:r="http://schemas.openxmlformats.org/officeDocument/2006/relationships" id="261" r:id="Rb7691c935bc841e3"/>
+    <p:sldId xmlns:r="http://schemas.openxmlformats.org/officeDocument/2006/relationships" id="262" r:id="R6039e2462f4e4695"/>
+    <p:sldId xmlns:r="http://schemas.openxmlformats.org/officeDocument/2006/relationships" id="263" r:id="R52465f53f5fb4d21"/>
+    <p:sldId xmlns:r="http://schemas.openxmlformats.org/officeDocument/2006/relationships" id="264" r:id="Ref9e3cd3a6294789"/>
+    <p:sldId xmlns:r="http://schemas.openxmlformats.org/officeDocument/2006/relationships" id="265" r:id="Rf1844720e12248b1"/>
+    <p:sldId xmlns:r="http://schemas.openxmlformats.org/officeDocument/2006/relationships" id="266" r:id="Rd059fef535ca4977"/>
+    <p:sldId xmlns:r="http://schemas.openxmlformats.org/officeDocument/2006/relationships" id="267" r:id="R038d712bbbd64b6c"/>
+    <p:sldId xmlns:r="http://schemas.openxmlformats.org/officeDocument/2006/relationships" id="268" r:id="R395cb0c87a22468b"/>
+    <p:sldId xmlns:r="http://schemas.openxmlformats.org/officeDocument/2006/relationships" id="269" r:id="R9af168dce30b4d72"/>
+    <p:sldId xmlns:r="http://schemas.openxmlformats.org/officeDocument/2006/relationships" id="270" r:id="R21deab66c21a4247"/>
   </p:sldIdLst>
   <p:sldSz cx="12192000" cy="6858000"/>
   <p:notesSz cx="6858000" cy="9144000"/>
@@ -1666,7 +1666,7 @@
           <p:cNvPr id="2" name="Text 0">
             <a:extLst xmlns:a="http://schemas.openxmlformats.org/drawingml/2006/main">
               <a:ext uri="{FF2B5EF4-FFF2-40B4-BE49-F238E27FC236}">
-                <a16:creationId xmlns:a16="http://schemas.microsoft.com/office/drawing/2014/main" id="{FFD94963-61C9-41D7-B8A7-93C5A8337554}"/>
+                <a16:creationId xmlns:a16="http://schemas.microsoft.com/office/drawing/2014/main" id="{ECE97334-1AA3-4B6C-B382-8A1103CC61EB}"/>
               </a:ext>
             </a:extLst>
           </p:cNvPr>
@@ -1712,7 +1712,7 @@
           <p:cNvPr id="3" name="Text 0">
             <a:extLst xmlns:a="http://schemas.openxmlformats.org/drawingml/2006/main">
               <a:ext uri="{FF2B5EF4-FFF2-40B4-BE49-F238E27FC236}">
-                <a16:creationId xmlns:a16="http://schemas.microsoft.com/office/drawing/2014/main" id="{1071312A-D9F5-42F6-B9C2-216D94B61E41}"/>
+                <a16:creationId xmlns:a16="http://schemas.microsoft.com/office/drawing/2014/main" id="{2332F513-6012-49A0-ADD8-1FC7B7AF0115}"/>
               </a:ext>
             </a:extLst>
           </p:cNvPr>
@@ -1782,7 +1782,7 @@
           <p:cNvPr id="2" name="Text 0">
             <a:extLst xmlns:a="http://schemas.openxmlformats.org/drawingml/2006/main">
               <a:ext uri="{FF2B5EF4-FFF2-40B4-BE49-F238E27FC236}">
-                <a16:creationId xmlns:a16="http://schemas.microsoft.com/office/drawing/2014/main" id="{EBE21347-A384-4546-A1A6-79C8523D48B9}"/>
+                <a16:creationId xmlns:a16="http://schemas.microsoft.com/office/drawing/2014/main" id="{899F014D-D0CE-4F88-B743-26153EDFEBFC}"/>
               </a:ext>
             </a:extLst>
           </p:cNvPr>
@@ -1828,7 +1828,7 @@
           <p:cNvPr id="3" name="Text 0">
             <a:extLst xmlns:a="http://schemas.openxmlformats.org/drawingml/2006/main">
               <a:ext uri="{FF2B5EF4-FFF2-40B4-BE49-F238E27FC236}">
-                <a16:creationId xmlns:a16="http://schemas.microsoft.com/office/drawing/2014/main" id="{0B4A36C2-B567-4ABF-A219-7967D7DAD639}"/>
+                <a16:creationId xmlns:a16="http://schemas.microsoft.com/office/drawing/2014/main" id="{B4EE4B8B-9722-44EB-9342-AD62B8B46833}"/>
               </a:ext>
             </a:extLst>
           </p:cNvPr>
@@ -1871,7 +1871,7 @@
           <p:cNvPr id="25" name="Slide Number Placeholder 0">
             <a:extLst xmlns:a="http://schemas.openxmlformats.org/drawingml/2006/main">
               <a:ext uri="{FF2B5EF4-FFF2-40B4-BE49-F238E27FC236}">
-                <a16:creationId xmlns:a16="http://schemas.microsoft.com/office/drawing/2014/main" id="{7578461C-24F8-4467-8A91-B4739B02B11B}"/>
+                <a16:creationId xmlns:a16="http://schemas.microsoft.com/office/drawing/2014/main" id="{B0B9A155-D5E8-4FC2-B364-36C264A82137}"/>
               </a:ext>
             </a:extLst>
           </p:cNvPr>
@@ -1937,7 +1937,7 @@
           <p:cNvPr id="25" name="Slide Number Placeholder 0">
             <a:extLst xmlns:a="http://schemas.openxmlformats.org/drawingml/2006/main">
               <a:ext uri="{FF2B5EF4-FFF2-40B4-BE49-F238E27FC236}">
-                <a16:creationId xmlns:a16="http://schemas.microsoft.com/office/drawing/2014/main" id="{0DAD27DB-DD45-41FC-9E87-44948749E2E2}"/>
+                <a16:creationId xmlns:a16="http://schemas.microsoft.com/office/drawing/2014/main" id="{A91BBD45-BF6A-434C-8DCB-8DF8150F2949}"/>
               </a:ext>
             </a:extLst>
           </p:cNvPr>
@@ -1985,9 +1985,9 @@
   </p:cSld>
   <p:clrMap bg1="lt1" tx1="dk1" bg2="lt2" tx2="dk2" accent1="accent1" accent2="accent2" accent3="accent3" accent4="accent4" accent5="accent5" accent6="accent6" hlink="hlink" folHlink="folHlink"/>
   <p:sldLayoutIdLst>
-    <p:sldLayoutId xmlns:r="http://schemas.openxmlformats.org/officeDocument/2006/relationships" id="2147483649" r:id="Reb883286659e4ab7"/>
-    <p:sldLayoutId xmlns:r="http://schemas.openxmlformats.org/officeDocument/2006/relationships" id="2147483650" r:id="R6face1a86cf34412"/>
-    <p:sldLayoutId xmlns:r="http://schemas.openxmlformats.org/officeDocument/2006/relationships" id="2147483651" r:id="Ra281674daae141be"/>
+    <p:sldLayoutId xmlns:r="http://schemas.openxmlformats.org/officeDocument/2006/relationships" id="2147483649" r:id="R12b983aac6dc4f64"/>
+    <p:sldLayoutId xmlns:r="http://schemas.openxmlformats.org/officeDocument/2006/relationships" id="2147483650" r:id="Rb2a08597c6204a0e"/>
+    <p:sldLayoutId xmlns:r="http://schemas.openxmlformats.org/officeDocument/2006/relationships" id="2147483651" r:id="R188b49f3eb334d78"/>
   </p:sldLayoutIdLst>
   <p:hf sldNum="0" hdr="0" ftr="0" dt="0"/>
   <p:txStyles>
@@ -2912,7 +2912,7 @@
           <p:cNvPr id="2" name="Text 0">
             <a:extLst xmlns:a="http://schemas.openxmlformats.org/drawingml/2006/main">
               <a:ext uri="{FF2B5EF4-FFF2-40B4-BE49-F238E27FC236}">
-                <a16:creationId xmlns:a16="http://schemas.microsoft.com/office/drawing/2014/main" id="{A93D52E9-EF71-4AB5-85E6-7A74679CB2AD}"/>
+                <a16:creationId xmlns:a16="http://schemas.microsoft.com/office/drawing/2014/main" id="{8B0E4FA7-3D7E-47F2-AA69-811DC7397265}"/>
               </a:ext>
             </a:extLst>
           </p:cNvPr>
@@ -2957,7 +2957,7 @@
           <p:cNvPr id="3" name="Text 0">
             <a:extLst xmlns:a="http://schemas.openxmlformats.org/drawingml/2006/main">
               <a:ext uri="{FF2B5EF4-FFF2-40B4-BE49-F238E27FC236}">
-                <a16:creationId xmlns:a16="http://schemas.microsoft.com/office/drawing/2014/main" id="{A7475947-3839-4AA2-8AB3-01E397DBF366}"/>
+                <a16:creationId xmlns:a16="http://schemas.microsoft.com/office/drawing/2014/main" id="{FDCDFE86-EA1C-4334-8A15-EF3A928C9AC4}"/>
               </a:ext>
             </a:extLst>
           </p:cNvPr>
@@ -3002,7 +3002,7 @@
           <p:cNvPr id="4" name="Text 2">
             <a:extLst xmlns:a="http://schemas.openxmlformats.org/drawingml/2006/main">
               <a:ext uri="{FF2B5EF4-FFF2-40B4-BE49-F238E27FC236}">
-                <a16:creationId xmlns:a16="http://schemas.microsoft.com/office/drawing/2014/main" id="{7B85E3AB-BD74-4E35-BE21-A48FE17A22F2}"/>
+                <a16:creationId xmlns:a16="http://schemas.microsoft.com/office/drawing/2014/main" id="{FB3A3BCC-0567-402F-B424-6A8CD1A596DC}"/>
               </a:ext>
             </a:extLst>
           </p:cNvPr>
@@ -3097,7 +3097,7 @@
     </p:spTree>
     <p:extLst>
       <p:ext uri="{BB962C8B-B14F-4D97-AF65-F5344CB8AC3E}">
-        <p14:creationId xmlns:p14="http://schemas.microsoft.com/office/powerpoint/2010/main" val="35936356"/>
+        <p14:creationId xmlns:p14="http://schemas.microsoft.com/office/powerpoint/2010/main" val="783080784"/>
       </p:ext>
     </p:extLst>
   </p:cSld>
@@ -3121,7 +3121,7 @@
           <p:cNvPr id="2" name="Text 0">
             <a:extLst xmlns:a="http://schemas.openxmlformats.org/drawingml/2006/main">
               <a:ext uri="{FF2B5EF4-FFF2-40B4-BE49-F238E27FC236}">
-                <a16:creationId xmlns:a16="http://schemas.microsoft.com/office/drawing/2014/main" id="{0645285C-FCFA-40D6-BBE3-AE77A74D0F80}"/>
+                <a16:creationId xmlns:a16="http://schemas.microsoft.com/office/drawing/2014/main" id="{DC8D30F4-F312-4425-896F-FB8484090ED1}"/>
               </a:ext>
             </a:extLst>
           </p:cNvPr>
@@ -3166,7 +3166,7 @@
           <p:cNvPr id="25" name="Slide Number Placeholder 0">
             <a:extLst xmlns:a="http://schemas.openxmlformats.org/drawingml/2006/main">
               <a:ext uri="{FF2B5EF4-FFF2-40B4-BE49-F238E27FC236}">
-                <a16:creationId xmlns:a16="http://schemas.microsoft.com/office/drawing/2014/main" id="{89CDBFAF-D7E5-4782-937C-5F51B7290C34}"/>
+                <a16:creationId xmlns:a16="http://schemas.microsoft.com/office/drawing/2014/main" id="{C9B5C426-F631-4D30-8083-E42490D04050}"/>
               </a:ext>
             </a:extLst>
           </p:cNvPr>
@@ -3215,7 +3215,7 @@
           <p:cNvPr id="26" name="Matrix 21 cases">
             <a:extLst xmlns:a="http://schemas.openxmlformats.org/drawingml/2006/main">
               <a:ext uri="{FF2B5EF4-FFF2-40B4-BE49-F238E27FC236}">
-                <a16:creationId xmlns:a16="http://schemas.microsoft.com/office/drawing/2014/main" id="{51902B37-9888-4D66-B669-C7770602BD5E}"/>
+                <a16:creationId xmlns:a16="http://schemas.microsoft.com/office/drawing/2014/main" id="{8B7292FB-CF22-44F0-82C7-4AFB3CB2AEEC}"/>
               </a:ext>
             </a:extLst>
           </p:cNvPr>
@@ -6112,7 +6112,7 @@
           <p:cNvPr id="27" name="test.each snippet">
             <a:extLst xmlns:a="http://schemas.openxmlformats.org/drawingml/2006/main">
               <a:ext uri="{FF2B5EF4-FFF2-40B4-BE49-F238E27FC236}">
-                <a16:creationId xmlns:a16="http://schemas.microsoft.com/office/drawing/2014/main" id="{4B9B94BF-6293-44C7-AE64-F3683FE3A0C5}"/>
+                <a16:creationId xmlns:a16="http://schemas.microsoft.com/office/drawing/2014/main" id="{9774397A-4332-46ED-AE41-C2D024C9357E}"/>
               </a:ext>
             </a:extLst>
           </p:cNvPr>
@@ -6243,7 +6243,7 @@
     </p:spTree>
     <p:extLst>
       <p:ext uri="{BB962C8B-B14F-4D97-AF65-F5344CB8AC3E}">
-        <p14:creationId xmlns:p14="http://schemas.microsoft.com/office/powerpoint/2010/main" val="1203558836"/>
+        <p14:creationId xmlns:p14="http://schemas.microsoft.com/office/powerpoint/2010/main" val="1681159755"/>
       </p:ext>
     </p:extLst>
   </p:cSld>
@@ -6267,7 +6267,7 @@
           <p:cNvPr id="2" name="Text 0">
             <a:extLst xmlns:a="http://schemas.openxmlformats.org/drawingml/2006/main">
               <a:ext uri="{FF2B5EF4-FFF2-40B4-BE49-F238E27FC236}">
-                <a16:creationId xmlns:a16="http://schemas.microsoft.com/office/drawing/2014/main" id="{39C6C886-9627-47BD-851D-F640F4DCA2D6}"/>
+                <a16:creationId xmlns:a16="http://schemas.microsoft.com/office/drawing/2014/main" id="{26FE84E5-E517-451A-8A25-6A861DBE767D}"/>
               </a:ext>
             </a:extLst>
           </p:cNvPr>
@@ -6312,7 +6312,7 @@
           <p:cNvPr id="4" name="Text 1">
             <a:extLst xmlns:a="http://schemas.openxmlformats.org/drawingml/2006/main">
               <a:ext uri="{FF2B5EF4-FFF2-40B4-BE49-F238E27FC236}">
-                <a16:creationId xmlns:a16="http://schemas.microsoft.com/office/drawing/2014/main" id="{2DF4ED48-C075-4A33-810B-6EA532DBA0A3}"/>
+                <a16:creationId xmlns:a16="http://schemas.microsoft.com/office/drawing/2014/main" id="{917F364F-402A-4345-8236-9B3FB8F7F47F}"/>
               </a:ext>
             </a:extLst>
           </p:cNvPr>
@@ -6366,7 +6366,7 @@
           <p:cNvPr id="5" name="Shape 2">
             <a:extLst xmlns:a="http://schemas.openxmlformats.org/drawingml/2006/main">
               <a:ext uri="{FF2B5EF4-FFF2-40B4-BE49-F238E27FC236}">
-                <a16:creationId xmlns:a16="http://schemas.microsoft.com/office/drawing/2014/main" id="{11E12CD9-20F3-40DF-A590-71D1F8AF356D}"/>
+                <a16:creationId xmlns:a16="http://schemas.microsoft.com/office/drawing/2014/main" id="{D66D6CA5-139F-4AA9-97E5-57D195AE37C4}"/>
               </a:ext>
             </a:extLst>
           </p:cNvPr>
@@ -6398,7 +6398,7 @@
           <p:cNvPr id="6" name="Text 3">
             <a:extLst xmlns:a="http://schemas.openxmlformats.org/drawingml/2006/main">
               <a:ext uri="{FF2B5EF4-FFF2-40B4-BE49-F238E27FC236}">
-                <a16:creationId xmlns:a16="http://schemas.microsoft.com/office/drawing/2014/main" id="{D3F9AEED-7509-42F2-B083-A2061912585E}"/>
+                <a16:creationId xmlns:a16="http://schemas.microsoft.com/office/drawing/2014/main" id="{36E2886B-C972-4B99-B03E-F2F546A9FBBB}"/>
               </a:ext>
             </a:extLst>
           </p:cNvPr>
@@ -6452,7 +6452,7 @@
           <p:cNvPr id="7" name="Shape 4">
             <a:extLst xmlns:a="http://schemas.openxmlformats.org/drawingml/2006/main">
               <a:ext uri="{FF2B5EF4-FFF2-40B4-BE49-F238E27FC236}">
-                <a16:creationId xmlns:a16="http://schemas.microsoft.com/office/drawing/2014/main" id="{1F46888D-669F-448D-B479-3B0E071F6204}"/>
+                <a16:creationId xmlns:a16="http://schemas.microsoft.com/office/drawing/2014/main" id="{086403AB-8890-4E38-B6DC-969E86CBDB08}"/>
               </a:ext>
             </a:extLst>
           </p:cNvPr>
@@ -6484,7 +6484,7 @@
           <p:cNvPr id="8" name="Text 5">
             <a:extLst xmlns:a="http://schemas.openxmlformats.org/drawingml/2006/main">
               <a:ext uri="{FF2B5EF4-FFF2-40B4-BE49-F238E27FC236}">
-                <a16:creationId xmlns:a16="http://schemas.microsoft.com/office/drawing/2014/main" id="{8D12A956-5ADF-413E-8E4C-9475096F26F2}"/>
+                <a16:creationId xmlns:a16="http://schemas.microsoft.com/office/drawing/2014/main" id="{D946923B-6E5F-4C6D-B4C9-0567E2128DBB}"/>
               </a:ext>
             </a:extLst>
           </p:cNvPr>
@@ -6555,7 +6555,7 @@
           <p:cNvPr id="9" name="Shape 6">
             <a:extLst xmlns:a="http://schemas.openxmlformats.org/drawingml/2006/main">
               <a:ext uri="{FF2B5EF4-FFF2-40B4-BE49-F238E27FC236}">
-                <a16:creationId xmlns:a16="http://schemas.microsoft.com/office/drawing/2014/main" id="{0E007F87-894B-4380-9507-89AB113A7A29}"/>
+                <a16:creationId xmlns:a16="http://schemas.microsoft.com/office/drawing/2014/main" id="{24F71A9E-50A8-416A-B017-98F4034863D2}"/>
               </a:ext>
             </a:extLst>
           </p:cNvPr>
@@ -6587,7 +6587,7 @@
           <p:cNvPr id="10" name="Text 7">
             <a:extLst xmlns:a="http://schemas.openxmlformats.org/drawingml/2006/main">
               <a:ext uri="{FF2B5EF4-FFF2-40B4-BE49-F238E27FC236}">
-                <a16:creationId xmlns:a16="http://schemas.microsoft.com/office/drawing/2014/main" id="{0ACD9B62-CB1E-49DA-8FCB-04A2B0C43D78}"/>
+                <a16:creationId xmlns:a16="http://schemas.microsoft.com/office/drawing/2014/main" id="{0E632868-2DE4-4B94-A87B-6E32783E9088}"/>
               </a:ext>
             </a:extLst>
           </p:cNvPr>
@@ -6641,7 +6641,7 @@
           <p:cNvPr id="11" name="Shape 8">
             <a:extLst xmlns:a="http://schemas.openxmlformats.org/drawingml/2006/main">
               <a:ext uri="{FF2B5EF4-FFF2-40B4-BE49-F238E27FC236}">
-                <a16:creationId xmlns:a16="http://schemas.microsoft.com/office/drawing/2014/main" id="{FDAF409E-2683-4A01-9F26-66D358B68E63}"/>
+                <a16:creationId xmlns:a16="http://schemas.microsoft.com/office/drawing/2014/main" id="{3DB56AA7-8E86-4389-BF7E-E9B1ED38C9E1}"/>
               </a:ext>
             </a:extLst>
           </p:cNvPr>
@@ -6673,7 +6673,7 @@
           <p:cNvPr id="12" name="Text 9">
             <a:extLst xmlns:a="http://schemas.openxmlformats.org/drawingml/2006/main">
               <a:ext uri="{FF2B5EF4-FFF2-40B4-BE49-F238E27FC236}">
-                <a16:creationId xmlns:a16="http://schemas.microsoft.com/office/drawing/2014/main" id="{FA6994A5-3A8A-4EE1-9EB8-D24254253D8C}"/>
+                <a16:creationId xmlns:a16="http://schemas.microsoft.com/office/drawing/2014/main" id="{1DBD7394-BDCB-4D6F-94DA-5EA420BF8F16}"/>
               </a:ext>
             </a:extLst>
           </p:cNvPr>
@@ -6727,7 +6727,7 @@
           <p:cNvPr id="13" name="Shape 10">
             <a:extLst xmlns:a="http://schemas.openxmlformats.org/drawingml/2006/main">
               <a:ext uri="{FF2B5EF4-FFF2-40B4-BE49-F238E27FC236}">
-                <a16:creationId xmlns:a16="http://schemas.microsoft.com/office/drawing/2014/main" id="{2ECA6C2F-430C-466B-BE1B-EC3BB943E9E2}"/>
+                <a16:creationId xmlns:a16="http://schemas.microsoft.com/office/drawing/2014/main" id="{F1574210-7D39-4407-997B-FE154A0CF18D}"/>
               </a:ext>
             </a:extLst>
           </p:cNvPr>
@@ -6759,7 +6759,7 @@
           <p:cNvPr id="14" name="Text 11">
             <a:extLst xmlns:a="http://schemas.openxmlformats.org/drawingml/2006/main">
               <a:ext uri="{FF2B5EF4-FFF2-40B4-BE49-F238E27FC236}">
-                <a16:creationId xmlns:a16="http://schemas.microsoft.com/office/drawing/2014/main" id="{AD057C83-69FF-4096-A710-B5086052295F}"/>
+                <a16:creationId xmlns:a16="http://schemas.microsoft.com/office/drawing/2014/main" id="{86DD88DC-2454-4645-8FA0-0678002795C8}"/>
               </a:ext>
             </a:extLst>
           </p:cNvPr>
@@ -6813,7 +6813,7 @@
           <p:cNvPr id="15" name="Text 12">
             <a:extLst xmlns:a="http://schemas.openxmlformats.org/drawingml/2006/main">
               <a:ext uri="{FF2B5EF4-FFF2-40B4-BE49-F238E27FC236}">
-                <a16:creationId xmlns:a16="http://schemas.microsoft.com/office/drawing/2014/main" id="{89B02AB5-EFE9-432D-A34D-B533C48B57D1}"/>
+                <a16:creationId xmlns:a16="http://schemas.microsoft.com/office/drawing/2014/main" id="{F27A1EEF-379C-454C-89AD-D2878F27EAC3}"/>
               </a:ext>
             </a:extLst>
           </p:cNvPr>
@@ -6884,7 +6884,7 @@
           <p:cNvPr id="16" name="Text 13">
             <a:extLst xmlns:a="http://schemas.openxmlformats.org/drawingml/2006/main">
               <a:ext uri="{FF2B5EF4-FFF2-40B4-BE49-F238E27FC236}">
-                <a16:creationId xmlns:a16="http://schemas.microsoft.com/office/drawing/2014/main" id="{80372F4C-A5AD-4D67-AC12-5363FFED9B58}"/>
+                <a16:creationId xmlns:a16="http://schemas.microsoft.com/office/drawing/2014/main" id="{E83A97C7-ECFC-4EDA-BA66-537F9F03FE94}"/>
               </a:ext>
             </a:extLst>
           </p:cNvPr>
@@ -6955,7 +6955,7 @@
           <p:cNvPr id="17" name="Text 14">
             <a:extLst xmlns:a="http://schemas.openxmlformats.org/drawingml/2006/main">
               <a:ext uri="{FF2B5EF4-FFF2-40B4-BE49-F238E27FC236}">
-                <a16:creationId xmlns:a16="http://schemas.microsoft.com/office/drawing/2014/main" id="{6628E5D3-B60F-4149-BA9D-5141CA1DB967}"/>
+                <a16:creationId xmlns:a16="http://schemas.microsoft.com/office/drawing/2014/main" id="{AA1FBA40-485E-4B7A-B5DE-A0D3091E1DBD}"/>
               </a:ext>
             </a:extLst>
           </p:cNvPr>
@@ -7054,7 +7054,7 @@
           <p:cNvPr id="18" name="Text 15">
             <a:extLst xmlns:a="http://schemas.openxmlformats.org/drawingml/2006/main">
               <a:ext uri="{FF2B5EF4-FFF2-40B4-BE49-F238E27FC236}">
-                <a16:creationId xmlns:a16="http://schemas.microsoft.com/office/drawing/2014/main" id="{36C9615A-F186-4E8E-9132-9499D2B7E8D6}"/>
+                <a16:creationId xmlns:a16="http://schemas.microsoft.com/office/drawing/2014/main" id="{3BCAD3BE-EC58-4B6C-B5E8-C7984CC886EE}"/>
               </a:ext>
             </a:extLst>
           </p:cNvPr>
@@ -7097,7 +7097,7 @@
           <p:cNvPr id="25" name="Slide Number Placeholder 0">
             <a:extLst xmlns:a="http://schemas.openxmlformats.org/drawingml/2006/main">
               <a:ext uri="{FF2B5EF4-FFF2-40B4-BE49-F238E27FC236}">
-                <a16:creationId xmlns:a16="http://schemas.microsoft.com/office/drawing/2014/main" id="{06C339FA-88A5-4FE3-AF34-6CB865DA4F97}"/>
+                <a16:creationId xmlns:a16="http://schemas.microsoft.com/office/drawing/2014/main" id="{4A85CA0D-7D25-49D8-827C-66C5A31C0571}"/>
               </a:ext>
             </a:extLst>
           </p:cNvPr>
@@ -7144,7 +7144,7 @@
     </p:spTree>
     <p:extLst>
       <p:ext uri="{BB962C8B-B14F-4D97-AF65-F5344CB8AC3E}">
-        <p14:creationId xmlns:p14="http://schemas.microsoft.com/office/powerpoint/2010/main" val="121292357"/>
+        <p14:creationId xmlns:p14="http://schemas.microsoft.com/office/powerpoint/2010/main" val="1027392936"/>
       </p:ext>
     </p:extLst>
   </p:cSld>
@@ -7168,7 +7168,7 @@
           <p:cNvPr id="2" name="Text 0">
             <a:extLst xmlns:a="http://schemas.openxmlformats.org/drawingml/2006/main">
               <a:ext uri="{FF2B5EF4-FFF2-40B4-BE49-F238E27FC236}">
-                <a16:creationId xmlns:a16="http://schemas.microsoft.com/office/drawing/2014/main" id="{E52D7601-A0B3-45BB-9453-85F755C9489B}"/>
+                <a16:creationId xmlns:a16="http://schemas.microsoft.com/office/drawing/2014/main" id="{668A95CB-813A-447A-8440-38BF4E41285B}"/>
               </a:ext>
             </a:extLst>
           </p:cNvPr>
@@ -7213,7 +7213,7 @@
           <p:cNvPr id="4" name="Chart 0">
             <a:extLst xmlns:a="http://schemas.openxmlformats.org/drawingml/2006/main">
               <a:ext uri="{FF2B5EF4-FFF2-40B4-BE49-F238E27FC236}">
-                <a16:creationId xmlns:a16="http://schemas.microsoft.com/office/drawing/2014/main" id="{8BF82E1C-D1AA-45BB-A330-2443862C2F44}"/>
+                <a16:creationId xmlns:a16="http://schemas.microsoft.com/office/drawing/2014/main" id="{8E1E3DF3-CA95-4EF0-979C-9E1AAEA94D5C}"/>
               </a:ext>
             </a:extLst>
           </p:cNvPr>
@@ -7226,7 +7226,7 @@
         </p:xfrm>
         <a:graphic xmlns:a="http://schemas.openxmlformats.org/drawingml/2006/main">
           <a:graphicData uri="http://schemas.openxmlformats.org/drawingml/2006/chart">
-            <c:chart xmlns:r="http://schemas.openxmlformats.org/officeDocument/2006/relationships" xmlns:c="http://schemas.openxmlformats.org/drawingml/2006/chart" r:id="Rf8b725680fe4421f"/>
+            <c:chart xmlns:r="http://schemas.openxmlformats.org/officeDocument/2006/relationships" xmlns:c="http://schemas.openxmlformats.org/drawingml/2006/chart" r:id="Rafdb61ccfc014f9a"/>
           </a:graphicData>
         </a:graphic>
       </p:graphicFrame>
@@ -7235,7 +7235,7 @@
           <p:cNvPr id="5" name="Text 1">
             <a:extLst xmlns:a="http://schemas.openxmlformats.org/drawingml/2006/main">
               <a:ext uri="{FF2B5EF4-FFF2-40B4-BE49-F238E27FC236}">
-                <a16:creationId xmlns:a16="http://schemas.microsoft.com/office/drawing/2014/main" id="{2F54704D-44D7-4E0E-AAC9-14B45691612C}"/>
+                <a16:creationId xmlns:a16="http://schemas.microsoft.com/office/drawing/2014/main" id="{553FFA16-5B4F-4453-AFF3-95EDC9884C36}"/>
               </a:ext>
             </a:extLst>
           </p:cNvPr>
@@ -7334,7 +7334,7 @@
           <p:cNvPr id="25" name="Slide Number Placeholder 0">
             <a:extLst xmlns:a="http://schemas.openxmlformats.org/drawingml/2006/main">
               <a:ext uri="{FF2B5EF4-FFF2-40B4-BE49-F238E27FC236}">
-                <a16:creationId xmlns:a16="http://schemas.microsoft.com/office/drawing/2014/main" id="{97F560EC-FDAD-4CBD-8657-D5DE9BDE37D6}"/>
+                <a16:creationId xmlns:a16="http://schemas.microsoft.com/office/drawing/2014/main" id="{62523413-2FB6-4C2F-B007-6298626F9E9B}"/>
               </a:ext>
             </a:extLst>
           </p:cNvPr>
@@ -7381,7 +7381,7 @@
     </p:spTree>
     <p:extLst>
       <p:ext uri="{BB962C8B-B14F-4D97-AF65-F5344CB8AC3E}">
-        <p14:creationId xmlns:p14="http://schemas.microsoft.com/office/powerpoint/2010/main" val="1508337323"/>
+        <p14:creationId xmlns:p14="http://schemas.microsoft.com/office/powerpoint/2010/main" val="1057277489"/>
       </p:ext>
     </p:extLst>
   </p:cSld>
@@ -7405,7 +7405,7 @@
           <p:cNvPr id="2" name="Text 0">
             <a:extLst xmlns:a="http://schemas.openxmlformats.org/drawingml/2006/main">
               <a:ext uri="{FF2B5EF4-FFF2-40B4-BE49-F238E27FC236}">
-                <a16:creationId xmlns:a16="http://schemas.microsoft.com/office/drawing/2014/main" id="{A7AEC66D-3601-4999-90E2-B2567866868A}"/>
+                <a16:creationId xmlns:a16="http://schemas.microsoft.com/office/drawing/2014/main" id="{D181D519-6CC2-43FF-9B2F-B314E28137B5}"/>
               </a:ext>
             </a:extLst>
           </p:cNvPr>
@@ -7450,7 +7450,7 @@
           <p:cNvPr id="4" name="Text 1">
             <a:extLst xmlns:a="http://schemas.openxmlformats.org/drawingml/2006/main">
               <a:ext uri="{FF2B5EF4-FFF2-40B4-BE49-F238E27FC236}">
-                <a16:creationId xmlns:a16="http://schemas.microsoft.com/office/drawing/2014/main" id="{79447819-8E68-4836-B363-74DD347545BB}"/>
+                <a16:creationId xmlns:a16="http://schemas.microsoft.com/office/drawing/2014/main" id="{673352D5-6F7F-4ACB-ACF8-3ADC1752C5C9}"/>
               </a:ext>
             </a:extLst>
           </p:cNvPr>
@@ -7521,7 +7521,7 @@
           <p:cNvPr id="5" name="Text 2">
             <a:extLst xmlns:a="http://schemas.openxmlformats.org/drawingml/2006/main">
               <a:ext uri="{FF2B5EF4-FFF2-40B4-BE49-F238E27FC236}">
-                <a16:creationId xmlns:a16="http://schemas.microsoft.com/office/drawing/2014/main" id="{32F915F5-CF5A-4593-8808-6CF4863A80C8}"/>
+                <a16:creationId xmlns:a16="http://schemas.microsoft.com/office/drawing/2014/main" id="{5C227E0E-6281-4757-9C91-39510A143A40}"/>
               </a:ext>
             </a:extLst>
           </p:cNvPr>
@@ -7575,7 +7575,7 @@
           <p:cNvPr id="6" name="Text 3">
             <a:extLst xmlns:a="http://schemas.openxmlformats.org/drawingml/2006/main">
               <a:ext uri="{FF2B5EF4-FFF2-40B4-BE49-F238E27FC236}">
-                <a16:creationId xmlns:a16="http://schemas.microsoft.com/office/drawing/2014/main" id="{5161F3CB-6202-4463-9C6D-15FB1114766E}"/>
+                <a16:creationId xmlns:a16="http://schemas.microsoft.com/office/drawing/2014/main" id="{E2048DCF-F886-4055-98C1-F1769DB7FA39}"/>
               </a:ext>
             </a:extLst>
           </p:cNvPr>
@@ -7635,7 +7635,7 @@
           <p:cNvPr id="7" name="Text 4">
             <a:extLst xmlns:a="http://schemas.openxmlformats.org/drawingml/2006/main">
               <a:ext uri="{FF2B5EF4-FFF2-40B4-BE49-F238E27FC236}">
-                <a16:creationId xmlns:a16="http://schemas.microsoft.com/office/drawing/2014/main" id="{46C43101-95E7-4991-BD08-07D966E3D7CA}"/>
+                <a16:creationId xmlns:a16="http://schemas.microsoft.com/office/drawing/2014/main" id="{07DA696E-C381-49A1-8830-133919C8FA62}"/>
               </a:ext>
             </a:extLst>
           </p:cNvPr>
@@ -7678,7 +7678,7 @@
           <p:cNvPr id="14" name="Table 0">
             <a:extLst xmlns:a="http://schemas.openxmlformats.org/drawingml/2006/main">
               <a:ext uri="{FF2B5EF4-FFF2-40B4-BE49-F238E27FC236}">
-                <a16:creationId xmlns:a16="http://schemas.microsoft.com/office/drawing/2014/main" id="{BC44A7D5-ED15-4FCD-A5CD-929E7082FDFC}"/>
+                <a16:creationId xmlns:a16="http://schemas.microsoft.com/office/drawing/2014/main" id="{E9CAA416-05B0-4456-BE9B-CA72A48833F8}"/>
               </a:ext>
             </a:extLst>
           </p:cNvPr>
@@ -8276,7 +8276,7 @@
           <p:cNvPr id="25" name="Slide Number Placeholder 0">
             <a:extLst xmlns:a="http://schemas.openxmlformats.org/drawingml/2006/main">
               <a:ext uri="{FF2B5EF4-FFF2-40B4-BE49-F238E27FC236}">
-                <a16:creationId xmlns:a16="http://schemas.microsoft.com/office/drawing/2014/main" id="{D59FA1DD-266F-44E2-A42D-1C723263EF00}"/>
+                <a16:creationId xmlns:a16="http://schemas.microsoft.com/office/drawing/2014/main" id="{9E69757A-5EAE-41F7-8AB2-306F59FDC51A}"/>
               </a:ext>
             </a:extLst>
           </p:cNvPr>
@@ -8323,7 +8323,7 @@
     </p:spTree>
     <p:extLst>
       <p:ext uri="{BB962C8B-B14F-4D97-AF65-F5344CB8AC3E}">
-        <p14:creationId xmlns:p14="http://schemas.microsoft.com/office/powerpoint/2010/main" val="2143809193"/>
+        <p14:creationId xmlns:p14="http://schemas.microsoft.com/office/powerpoint/2010/main" val="761286104"/>
       </p:ext>
     </p:extLst>
   </p:cSld>
@@ -8347,7 +8347,7 @@
           <p:cNvPr id="2" name="Text 0">
             <a:extLst xmlns:a="http://schemas.openxmlformats.org/drawingml/2006/main">
               <a:ext uri="{FF2B5EF4-FFF2-40B4-BE49-F238E27FC236}">
-                <a16:creationId xmlns:a16="http://schemas.microsoft.com/office/drawing/2014/main" id="{8F9A19ED-A0F8-4124-856D-4A6C275B4784}"/>
+                <a16:creationId xmlns:a16="http://schemas.microsoft.com/office/drawing/2014/main" id="{740037E4-255B-486F-A27F-88BF6F345CD6}"/>
               </a:ext>
             </a:extLst>
           </p:cNvPr>
@@ -8392,7 +8392,7 @@
           <p:cNvPr id="4" name="Text 1">
             <a:extLst xmlns:a="http://schemas.openxmlformats.org/drawingml/2006/main">
               <a:ext uri="{FF2B5EF4-FFF2-40B4-BE49-F238E27FC236}">
-                <a16:creationId xmlns:a16="http://schemas.microsoft.com/office/drawing/2014/main" id="{E47FBF39-3E08-4005-92C5-61C73D1FC54A}"/>
+                <a16:creationId xmlns:a16="http://schemas.microsoft.com/office/drawing/2014/main" id="{34C5BC14-0D5A-4D09-87EE-F08F7E49604C}"/>
               </a:ext>
             </a:extLst>
           </p:cNvPr>
@@ -8516,7 +8516,7 @@
           <p:cNvPr id="5" name="Text 2">
             <a:extLst xmlns:a="http://schemas.openxmlformats.org/drawingml/2006/main">
               <a:ext uri="{FF2B5EF4-FFF2-40B4-BE49-F238E27FC236}">
-                <a16:creationId xmlns:a16="http://schemas.microsoft.com/office/drawing/2014/main" id="{74F49913-9E2D-40DB-980C-9C4B8BFE3506}"/>
+                <a16:creationId xmlns:a16="http://schemas.microsoft.com/office/drawing/2014/main" id="{90ECA7BA-EDF8-4BFC-8D6C-1CFA6A6512C3}"/>
               </a:ext>
             </a:extLst>
           </p:cNvPr>
@@ -8554,7 +8554,7 @@
               <a:buNone/>
             </a:pPr>
             <a:r>
-              <a:rPr sz="2400" b="1">
+              <a:rPr sz="1600">
                 <a:solidFill>
                   <a:schemeClr val="tx1"/>
                 </a:solidFill>
@@ -8562,7 +8562,7 @@
                 <a:ea typeface="Arial"/>
                 <a:cs typeface="Arial"/>
               </a:rPr>
-              <a:t>Video demo: chưa có file trong repo</a:t>
+              <a:t>Link video:</a:t>
             </a:r>
             <a:endParaRPr sz="1400"/>
           </a:p>
@@ -8574,35 +8574,16 @@
               <a:buNone/>
             </a:pPr>
             <a:r>
-              <a:rPr sz="1600">
+              <a:rPr sz="1800">
                 <a:solidFill>
                   <a:schemeClr val="tx1"/>
                 </a:solidFill>
                 <a:latin typeface="Arial"/>
                 <a:ea typeface="Arial"/>
                 <a:cs typeface="Arial"/>
-              </a:rPr>
-              <a:t>Link video:</a:t>
-            </a:r>
-            <a:endParaRPr sz="1400"/>
-          </a:p>
-          <a:p xmlns:a="http://schemas.openxmlformats.org/drawingml/2006/main">
-            <a:pPr marL="0" indent="0" algn="ctr">
-              <a:spcAft>
-                <a:spcPts val="1000"/>
-              </a:spcAft>
-              <a:buNone/>
-            </a:pPr>
-            <a:r>
-              <a:rPr sz="1800">
-                <a:solidFill>
-                  <a:schemeClr val="tx1"/>
-                </a:solidFill>
-                <a:latin typeface="Arial"/>
-                <a:ea typeface="Arial"/>
-                <a:cs typeface="Arial"/>
-              </a:rPr>
-              <a:t>Bổ sung URL khi có video</a:t>
+                <a:hlinkClick xmlns:r="http://schemas.openxmlformats.org/officeDocument/2006/relationships" r:id="R187f9876a4674346"/>
+              </a:rPr>
+              <a:t>Xem video trên YouTube</a:t>
             </a:r>
             <a:endParaRPr sz="1400"/>
           </a:p>
@@ -8613,7 +8594,7 @@
           <p:cNvPr id="25" name="Slide Number Placeholder 0">
             <a:extLst xmlns:a="http://schemas.openxmlformats.org/drawingml/2006/main">
               <a:ext uri="{FF2B5EF4-FFF2-40B4-BE49-F238E27FC236}">
-                <a16:creationId xmlns:a16="http://schemas.microsoft.com/office/drawing/2014/main" id="{60530730-4745-47BD-939A-717F89619564}"/>
+                <a16:creationId xmlns:a16="http://schemas.microsoft.com/office/drawing/2014/main" id="{6BA8AC6F-2BF3-47B9-9633-3835B5001527}"/>
               </a:ext>
             </a:extLst>
           </p:cNvPr>
@@ -8660,7 +8641,7 @@
     </p:spTree>
     <p:extLst>
       <p:ext uri="{BB962C8B-B14F-4D97-AF65-F5344CB8AC3E}">
-        <p14:creationId xmlns:p14="http://schemas.microsoft.com/office/powerpoint/2010/main" val="1335658826"/>
+        <p14:creationId xmlns:p14="http://schemas.microsoft.com/office/powerpoint/2010/main" val="1997656047"/>
       </p:ext>
     </p:extLst>
   </p:cSld>
@@ -8684,7 +8665,7 @@
           <p:cNvPr id="2" name="Text 0">
             <a:extLst xmlns:a="http://schemas.openxmlformats.org/drawingml/2006/main">
               <a:ext uri="{FF2B5EF4-FFF2-40B4-BE49-F238E27FC236}">
-                <a16:creationId xmlns:a16="http://schemas.microsoft.com/office/drawing/2014/main" id="{FAB7D340-CD6A-4521-B7EB-F74112AB3BE1}"/>
+                <a16:creationId xmlns:a16="http://schemas.microsoft.com/office/drawing/2014/main" id="{277D1676-5295-4C28-AC66-B3E11347EDFE}"/>
               </a:ext>
             </a:extLst>
           </p:cNvPr>
@@ -8729,7 +8710,7 @@
           <p:cNvPr id="4" name="Text 1">
             <a:extLst xmlns:a="http://schemas.openxmlformats.org/drawingml/2006/main">
               <a:ext uri="{FF2B5EF4-FFF2-40B4-BE49-F238E27FC236}">
-                <a16:creationId xmlns:a16="http://schemas.microsoft.com/office/drawing/2014/main" id="{D3CCEB75-208B-4232-9CD5-495077293B0F}"/>
+                <a16:creationId xmlns:a16="http://schemas.microsoft.com/office/drawing/2014/main" id="{84F16ACE-4E15-4313-86F2-DE89BD8CB2C9}"/>
               </a:ext>
             </a:extLst>
           </p:cNvPr>
@@ -8815,7 +8796,7 @@
           <p:cNvPr id="5" name="Text 2">
             <a:extLst xmlns:a="http://schemas.openxmlformats.org/drawingml/2006/main">
               <a:ext uri="{FF2B5EF4-FFF2-40B4-BE49-F238E27FC236}">
-                <a16:creationId xmlns:a16="http://schemas.microsoft.com/office/drawing/2014/main" id="{2B1432D1-A7CB-4AD5-A36E-81C859862585}"/>
+                <a16:creationId xmlns:a16="http://schemas.microsoft.com/office/drawing/2014/main" id="{73DC3F86-EEBE-490B-8A91-4035E1C55361}"/>
               </a:ext>
             </a:extLst>
           </p:cNvPr>
@@ -8935,7 +8916,7 @@
           <p:cNvPr id="6" name="Text 3">
             <a:extLst xmlns:a="http://schemas.openxmlformats.org/drawingml/2006/main">
               <a:ext uri="{FF2B5EF4-FFF2-40B4-BE49-F238E27FC236}">
-                <a16:creationId xmlns:a16="http://schemas.microsoft.com/office/drawing/2014/main" id="{23E7CF67-FE5F-4D58-A098-B16101BB4ACA}"/>
+                <a16:creationId xmlns:a16="http://schemas.microsoft.com/office/drawing/2014/main" id="{1FF6C1BD-2523-45B8-BA4B-5D14120EABEC}"/>
               </a:ext>
             </a:extLst>
           </p:cNvPr>
@@ -8974,17 +8955,9 @@
                 <a:solidFill>
                   <a:schemeClr val="tx1"/>
                 </a:solidFill>
-                <a:hlinkClick xmlns:r="http://schemas.openxmlformats.org/officeDocument/2006/relationships" r:id="R0c1d87e8ed934945"/>
+                <a:hlinkClick xmlns:r="http://schemas.openxmlformats.org/officeDocument/2006/relationships" r:id="R00237bd217ba4c42"/>
               </a:rPr>
               <a:t>github.com/SoftwareTesting-Group13/eshop-sut-seminar</a:t>
-            </a:r>
-            <a:r>
-              <a:rPr sz="1800" b="1">
-                <a:solidFill>
-                  <a:schemeClr val="tx1"/>
-                </a:solidFill>
-              </a:rPr>
-              <a:t>   ·   Cảm ơn thầy cô và các bạn. Q&amp;A</a:t>
             </a:r>
             <a:endParaRPr sz="1800"/>
           </a:p>
@@ -8995,7 +8968,7 @@
           <p:cNvPr id="25" name="Slide Number Placeholder 0">
             <a:extLst xmlns:a="http://schemas.openxmlformats.org/drawingml/2006/main">
               <a:ext uri="{FF2B5EF4-FFF2-40B4-BE49-F238E27FC236}">
-                <a16:creationId xmlns:a16="http://schemas.microsoft.com/office/drawing/2014/main" id="{935F5C9D-9B5A-4D61-8B8D-4DD15DA0E694}"/>
+                <a16:creationId xmlns:a16="http://schemas.microsoft.com/office/drawing/2014/main" id="{3334D437-A923-4999-BA78-91A356D8941A}"/>
               </a:ext>
             </a:extLst>
           </p:cNvPr>
@@ -9042,7 +9015,7 @@
     </p:spTree>
     <p:extLst>
       <p:ext uri="{BB962C8B-B14F-4D97-AF65-F5344CB8AC3E}">
-        <p14:creationId xmlns:p14="http://schemas.microsoft.com/office/powerpoint/2010/main" val="450356669"/>
+        <p14:creationId xmlns:p14="http://schemas.microsoft.com/office/powerpoint/2010/main" val="1834536095"/>
       </p:ext>
     </p:extLst>
   </p:cSld>
@@ -9066,7 +9039,7 @@
           <p:cNvPr id="2" name="Text 0">
             <a:extLst xmlns:a="http://schemas.openxmlformats.org/drawingml/2006/main">
               <a:ext uri="{FF2B5EF4-FFF2-40B4-BE49-F238E27FC236}">
-                <a16:creationId xmlns:a16="http://schemas.microsoft.com/office/drawing/2014/main" id="{986BE8F6-87CA-40F3-A6ED-A3023E0E8033}"/>
+                <a16:creationId xmlns:a16="http://schemas.microsoft.com/office/drawing/2014/main" id="{77E5F618-BEB1-47B6-BB59-7FC41EAE582F}"/>
               </a:ext>
             </a:extLst>
           </p:cNvPr>
@@ -9111,7 +9084,7 @@
           <p:cNvPr id="4" name="Text 1">
             <a:extLst xmlns:a="http://schemas.openxmlformats.org/drawingml/2006/main">
               <a:ext uri="{FF2B5EF4-FFF2-40B4-BE49-F238E27FC236}">
-                <a16:creationId xmlns:a16="http://schemas.microsoft.com/office/drawing/2014/main" id="{1361B0F4-440C-450D-BD39-45B2C63C3D77}"/>
+                <a16:creationId xmlns:a16="http://schemas.microsoft.com/office/drawing/2014/main" id="{63AA0BFA-07BC-4C70-8B0A-A6BD021A7DEF}"/>
               </a:ext>
             </a:extLst>
           </p:cNvPr>
@@ -9156,7 +9129,7 @@
           <p:cNvPr id="5" name="Text 2">
             <a:extLst xmlns:a="http://schemas.openxmlformats.org/drawingml/2006/main">
               <a:ext uri="{FF2B5EF4-FFF2-40B4-BE49-F238E27FC236}">
-                <a16:creationId xmlns:a16="http://schemas.microsoft.com/office/drawing/2014/main" id="{1826514A-AF1D-4FEF-A519-8FB94E78E822}"/>
+                <a16:creationId xmlns:a16="http://schemas.microsoft.com/office/drawing/2014/main" id="{B08A0F47-1A94-4B43-BB0D-5F85B230EC8F}"/>
               </a:ext>
             </a:extLst>
           </p:cNvPr>
@@ -9213,7 +9186,7 @@
           <p:cNvPr id="6" name="Text 3">
             <a:extLst xmlns:a="http://schemas.openxmlformats.org/drawingml/2006/main">
               <a:ext uri="{FF2B5EF4-FFF2-40B4-BE49-F238E27FC236}">
-                <a16:creationId xmlns:a16="http://schemas.microsoft.com/office/drawing/2014/main" id="{4B1BA8A0-A15E-43FE-98E9-B09775804EBA}"/>
+                <a16:creationId xmlns:a16="http://schemas.microsoft.com/office/drawing/2014/main" id="{EE864602-6357-4BAF-B081-6EE586588091}"/>
               </a:ext>
             </a:extLst>
           </p:cNvPr>
@@ -9258,7 +9231,7 @@
           <p:cNvPr id="7" name="Text 4">
             <a:extLst xmlns:a="http://schemas.openxmlformats.org/drawingml/2006/main">
               <a:ext uri="{FF2B5EF4-FFF2-40B4-BE49-F238E27FC236}">
-                <a16:creationId xmlns:a16="http://schemas.microsoft.com/office/drawing/2014/main" id="{4B3630F3-3FE3-4BB1-99E8-4DA1ED4F3DEB}"/>
+                <a16:creationId xmlns:a16="http://schemas.microsoft.com/office/drawing/2014/main" id="{C8ABFA17-1BF8-4D44-A764-BDB01C54EB53}"/>
               </a:ext>
             </a:extLst>
           </p:cNvPr>
@@ -9315,7 +9288,7 @@
           <p:cNvPr id="8" name="Text 5">
             <a:extLst xmlns:a="http://schemas.openxmlformats.org/drawingml/2006/main">
               <a:ext uri="{FF2B5EF4-FFF2-40B4-BE49-F238E27FC236}">
-                <a16:creationId xmlns:a16="http://schemas.microsoft.com/office/drawing/2014/main" id="{C6283E3C-7AE2-4B6E-9317-163D4EF844CF}"/>
+                <a16:creationId xmlns:a16="http://schemas.microsoft.com/office/drawing/2014/main" id="{93D3D3DF-8730-4D78-82A8-EFB46604B7B5}"/>
               </a:ext>
             </a:extLst>
           </p:cNvPr>
@@ -9360,7 +9333,7 @@
           <p:cNvPr id="9" name="Text 6">
             <a:extLst xmlns:a="http://schemas.openxmlformats.org/drawingml/2006/main">
               <a:ext uri="{FF2B5EF4-FFF2-40B4-BE49-F238E27FC236}">
-                <a16:creationId xmlns:a16="http://schemas.microsoft.com/office/drawing/2014/main" id="{81C6669C-43FA-4284-B38A-452236878BE4}"/>
+                <a16:creationId xmlns:a16="http://schemas.microsoft.com/office/drawing/2014/main" id="{41D98BD2-E2E2-4F79-BBE8-9CF937340645}"/>
               </a:ext>
             </a:extLst>
           </p:cNvPr>
@@ -9417,7 +9390,7 @@
           <p:cNvPr id="10" name="Text 7">
             <a:extLst xmlns:a="http://schemas.openxmlformats.org/drawingml/2006/main">
               <a:ext uri="{FF2B5EF4-FFF2-40B4-BE49-F238E27FC236}">
-                <a16:creationId xmlns:a16="http://schemas.microsoft.com/office/drawing/2014/main" id="{00D362BC-B16A-433E-BDD9-91858BF82F26}"/>
+                <a16:creationId xmlns:a16="http://schemas.microsoft.com/office/drawing/2014/main" id="{65E7946E-2A16-4F1F-AEBD-01E47AF9B769}"/>
               </a:ext>
             </a:extLst>
           </p:cNvPr>
@@ -9471,7 +9444,7 @@
           <p:cNvPr id="25" name="Slide Number Placeholder 0">
             <a:extLst xmlns:a="http://schemas.openxmlformats.org/drawingml/2006/main">
               <a:ext uri="{FF2B5EF4-FFF2-40B4-BE49-F238E27FC236}">
-                <a16:creationId xmlns:a16="http://schemas.microsoft.com/office/drawing/2014/main" id="{E254258C-07BC-4A7C-99A5-B28B8FB8A211}"/>
+                <a16:creationId xmlns:a16="http://schemas.microsoft.com/office/drawing/2014/main" id="{38CD3DC7-405B-4807-B7C1-8EB340CD9F35}"/>
               </a:ext>
             </a:extLst>
           </p:cNvPr>
@@ -9518,7 +9491,7 @@
     </p:spTree>
     <p:extLst>
       <p:ext uri="{BB962C8B-B14F-4D97-AF65-F5344CB8AC3E}">
-        <p14:creationId xmlns:p14="http://schemas.microsoft.com/office/powerpoint/2010/main" val="1762560153"/>
+        <p14:creationId xmlns:p14="http://schemas.microsoft.com/office/powerpoint/2010/main" val="1404664935"/>
       </p:ext>
     </p:extLst>
   </p:cSld>
@@ -9542,7 +9515,7 @@
           <p:cNvPr id="2" name="Text 0">
             <a:extLst xmlns:a="http://schemas.openxmlformats.org/drawingml/2006/main">
               <a:ext uri="{FF2B5EF4-FFF2-40B4-BE49-F238E27FC236}">
-                <a16:creationId xmlns:a16="http://schemas.microsoft.com/office/drawing/2014/main" id="{B24B2BB9-9964-4AE8-9638-44794FC810F5}"/>
+                <a16:creationId xmlns:a16="http://schemas.microsoft.com/office/drawing/2014/main" id="{C8857E7C-4070-4E87-95B0-FFC0EF4297C9}"/>
               </a:ext>
             </a:extLst>
           </p:cNvPr>
@@ -9587,7 +9560,7 @@
           <p:cNvPr id="4" name="Text 1">
             <a:extLst xmlns:a="http://schemas.openxmlformats.org/drawingml/2006/main">
               <a:ext uri="{FF2B5EF4-FFF2-40B4-BE49-F238E27FC236}">
-                <a16:creationId xmlns:a16="http://schemas.microsoft.com/office/drawing/2014/main" id="{02D559CA-6EAB-4CA6-A1F8-D105263B893D}"/>
+                <a16:creationId xmlns:a16="http://schemas.microsoft.com/office/drawing/2014/main" id="{2A378078-4144-41D1-A2AA-297C70DF96D8}"/>
               </a:ext>
             </a:extLst>
           </p:cNvPr>
@@ -9658,7 +9631,7 @@
           <p:cNvPr id="5" name="Text 2">
             <a:extLst xmlns:a="http://schemas.openxmlformats.org/drawingml/2006/main">
               <a:ext uri="{FF2B5EF4-FFF2-40B4-BE49-F238E27FC236}">
-                <a16:creationId xmlns:a16="http://schemas.microsoft.com/office/drawing/2014/main" id="{C5A0482C-6495-44D3-BB00-CF2047196B49}"/>
+                <a16:creationId xmlns:a16="http://schemas.microsoft.com/office/drawing/2014/main" id="{A03D0829-ACFC-48FB-859F-D982377DCA56}"/>
               </a:ext>
             </a:extLst>
           </p:cNvPr>
@@ -9729,7 +9702,7 @@
           <p:cNvPr id="6" name="Text 3">
             <a:extLst xmlns:a="http://schemas.openxmlformats.org/drawingml/2006/main">
               <a:ext uri="{FF2B5EF4-FFF2-40B4-BE49-F238E27FC236}">
-                <a16:creationId xmlns:a16="http://schemas.microsoft.com/office/drawing/2014/main" id="{91F6B7BB-8839-4D60-8C61-A2022F5A2341}"/>
+                <a16:creationId xmlns:a16="http://schemas.microsoft.com/office/drawing/2014/main" id="{485AEF72-A95E-44B2-8C09-8657F4F81EF7}"/>
               </a:ext>
             </a:extLst>
           </p:cNvPr>
@@ -9800,7 +9773,7 @@
           <p:cNvPr id="7" name="Text 4">
             <a:extLst xmlns:a="http://schemas.openxmlformats.org/drawingml/2006/main">
               <a:ext uri="{FF2B5EF4-FFF2-40B4-BE49-F238E27FC236}">
-                <a16:creationId xmlns:a16="http://schemas.microsoft.com/office/drawing/2014/main" id="{16199FCE-BDA5-4B25-A7E9-E30FC369327F}"/>
+                <a16:creationId xmlns:a16="http://schemas.microsoft.com/office/drawing/2014/main" id="{9087C86E-54C7-4F30-BE63-24EB5137B3E7}"/>
               </a:ext>
             </a:extLst>
           </p:cNvPr>
@@ -9871,7 +9844,7 @@
           <p:cNvPr id="8" name="Shape 5">
             <a:extLst xmlns:a="http://schemas.openxmlformats.org/drawingml/2006/main">
               <a:ext uri="{FF2B5EF4-FFF2-40B4-BE49-F238E27FC236}">
-                <a16:creationId xmlns:a16="http://schemas.microsoft.com/office/drawing/2014/main" id="{09E81168-9DAC-4AAA-B3BD-7902D0CCD8EB}"/>
+                <a16:creationId xmlns:a16="http://schemas.microsoft.com/office/drawing/2014/main" id="{568DB44F-B606-4EF4-88EE-AA8E8C331454}"/>
               </a:ext>
             </a:extLst>
           </p:cNvPr>
@@ -9903,7 +9876,7 @@
           <p:cNvPr id="9" name="Shape 6">
             <a:extLst xmlns:a="http://schemas.openxmlformats.org/drawingml/2006/main">
               <a:ext uri="{FF2B5EF4-FFF2-40B4-BE49-F238E27FC236}">
-                <a16:creationId xmlns:a16="http://schemas.microsoft.com/office/drawing/2014/main" id="{3A1609E8-D954-4C95-88DE-9F6229A80E4F}"/>
+                <a16:creationId xmlns:a16="http://schemas.microsoft.com/office/drawing/2014/main" id="{BD91D179-D357-4DAE-9D1F-FF7750458C7A}"/>
               </a:ext>
             </a:extLst>
           </p:cNvPr>
@@ -9935,7 +9908,7 @@
           <p:cNvPr id="10" name="Shape 7">
             <a:extLst xmlns:a="http://schemas.openxmlformats.org/drawingml/2006/main">
               <a:ext uri="{FF2B5EF4-FFF2-40B4-BE49-F238E27FC236}">
-                <a16:creationId xmlns:a16="http://schemas.microsoft.com/office/drawing/2014/main" id="{4B13E8DB-6178-4730-A2C1-53BE4D648B6D}"/>
+                <a16:creationId xmlns:a16="http://schemas.microsoft.com/office/drawing/2014/main" id="{8F7CBA3D-E524-40DC-AA2A-A4574F7424AC}"/>
               </a:ext>
             </a:extLst>
           </p:cNvPr>
@@ -9967,7 +9940,7 @@
           <p:cNvPr id="11" name="Text 8">
             <a:extLst xmlns:a="http://schemas.openxmlformats.org/drawingml/2006/main">
               <a:ext uri="{FF2B5EF4-FFF2-40B4-BE49-F238E27FC236}">
-                <a16:creationId xmlns:a16="http://schemas.microsoft.com/office/drawing/2014/main" id="{9BDFBCE3-937F-4542-A1FF-93E662D3433C}"/>
+                <a16:creationId xmlns:a16="http://schemas.microsoft.com/office/drawing/2014/main" id="{62D92343-2A21-4D86-9187-C19DABD1A909}"/>
               </a:ext>
             </a:extLst>
           </p:cNvPr>
@@ -10038,7 +10011,7 @@
           <p:cNvPr id="12" name="Shape 9">
             <a:extLst xmlns:a="http://schemas.openxmlformats.org/drawingml/2006/main">
               <a:ext uri="{FF2B5EF4-FFF2-40B4-BE49-F238E27FC236}">
-                <a16:creationId xmlns:a16="http://schemas.microsoft.com/office/drawing/2014/main" id="{3D319226-407E-4F51-83A1-691F6D8B1455}"/>
+                <a16:creationId xmlns:a16="http://schemas.microsoft.com/office/drawing/2014/main" id="{8C884A2F-B0F6-4D17-9EC3-9F4FCF2A69EC}"/>
               </a:ext>
             </a:extLst>
           </p:cNvPr>
@@ -10070,7 +10043,7 @@
           <p:cNvPr id="13" name="Text 10">
             <a:extLst xmlns:a="http://schemas.openxmlformats.org/drawingml/2006/main">
               <a:ext uri="{FF2B5EF4-FFF2-40B4-BE49-F238E27FC236}">
-                <a16:creationId xmlns:a16="http://schemas.microsoft.com/office/drawing/2014/main" id="{ACD45E89-3BCE-40E7-962F-332760505841}"/>
+                <a16:creationId xmlns:a16="http://schemas.microsoft.com/office/drawing/2014/main" id="{ABEE4FE8-828D-41F4-A489-4027E1FA3679}"/>
               </a:ext>
             </a:extLst>
           </p:cNvPr>
@@ -10141,7 +10114,7 @@
           <p:cNvPr id="14" name="Shape 11">
             <a:extLst xmlns:a="http://schemas.openxmlformats.org/drawingml/2006/main">
               <a:ext uri="{FF2B5EF4-FFF2-40B4-BE49-F238E27FC236}">
-                <a16:creationId xmlns:a16="http://schemas.microsoft.com/office/drawing/2014/main" id="{33AD83CA-9B97-43AB-B5DE-56D0AE24145C}"/>
+                <a16:creationId xmlns:a16="http://schemas.microsoft.com/office/drawing/2014/main" id="{F9658C52-B9EF-46BC-B90A-5469F199591D}"/>
               </a:ext>
             </a:extLst>
           </p:cNvPr>
@@ -10173,7 +10146,7 @@
           <p:cNvPr id="15" name="Text 12">
             <a:extLst xmlns:a="http://schemas.openxmlformats.org/drawingml/2006/main">
               <a:ext uri="{FF2B5EF4-FFF2-40B4-BE49-F238E27FC236}">
-                <a16:creationId xmlns:a16="http://schemas.microsoft.com/office/drawing/2014/main" id="{086CD803-37E7-4C43-BFCD-E31061715B5B}"/>
+                <a16:creationId xmlns:a16="http://schemas.microsoft.com/office/drawing/2014/main" id="{66FB8DCA-A93A-4B83-A883-97AE0425461A}"/>
               </a:ext>
             </a:extLst>
           </p:cNvPr>
@@ -10216,7 +10189,7 @@
           <p:cNvPr id="25" name="Slide Number Placeholder 0">
             <a:extLst xmlns:a="http://schemas.openxmlformats.org/drawingml/2006/main">
               <a:ext uri="{FF2B5EF4-FFF2-40B4-BE49-F238E27FC236}">
-                <a16:creationId xmlns:a16="http://schemas.microsoft.com/office/drawing/2014/main" id="{B0908617-6363-41B2-85F1-B274381D641F}"/>
+                <a16:creationId xmlns:a16="http://schemas.microsoft.com/office/drawing/2014/main" id="{6CBFCDF4-7BF9-4495-9AA2-3100FB24266D}"/>
               </a:ext>
             </a:extLst>
           </p:cNvPr>
@@ -10263,7 +10236,7 @@
     </p:spTree>
     <p:extLst>
       <p:ext uri="{BB962C8B-B14F-4D97-AF65-F5344CB8AC3E}">
-        <p14:creationId xmlns:p14="http://schemas.microsoft.com/office/powerpoint/2010/main" val="620599680"/>
+        <p14:creationId xmlns:p14="http://schemas.microsoft.com/office/powerpoint/2010/main" val="223894760"/>
       </p:ext>
     </p:extLst>
   </p:cSld>
@@ -10287,7 +10260,7 @@
           <p:cNvPr id="2" name="Text 0">
             <a:extLst xmlns:a="http://schemas.openxmlformats.org/drawingml/2006/main">
               <a:ext uri="{FF2B5EF4-FFF2-40B4-BE49-F238E27FC236}">
-                <a16:creationId xmlns:a16="http://schemas.microsoft.com/office/drawing/2014/main" id="{357A1ACE-6E85-4838-9D1D-AEA4B85C60A6}"/>
+                <a16:creationId xmlns:a16="http://schemas.microsoft.com/office/drawing/2014/main" id="{79D40E81-3D5D-4999-AD9D-E6F384A006E6}"/>
               </a:ext>
             </a:extLst>
           </p:cNvPr>
@@ -10332,7 +10305,7 @@
           <p:cNvPr id="4" name="Text 1">
             <a:extLst xmlns:a="http://schemas.openxmlformats.org/drawingml/2006/main">
               <a:ext uri="{FF2B5EF4-FFF2-40B4-BE49-F238E27FC236}">
-                <a16:creationId xmlns:a16="http://schemas.microsoft.com/office/drawing/2014/main" id="{D4AE0CAE-6F7C-4088-9530-483502E41415}"/>
+                <a16:creationId xmlns:a16="http://schemas.microsoft.com/office/drawing/2014/main" id="{AE7A2A1C-CA09-4567-A140-AB79ABCC5F51}"/>
               </a:ext>
             </a:extLst>
           </p:cNvPr>
@@ -10429,7 +10402,7 @@
           <p:cNvPr id="5" name="Text 2">
             <a:extLst xmlns:a="http://schemas.openxmlformats.org/drawingml/2006/main">
               <a:ext uri="{FF2B5EF4-FFF2-40B4-BE49-F238E27FC236}">
-                <a16:creationId xmlns:a16="http://schemas.microsoft.com/office/drawing/2014/main" id="{E68749A7-56D0-475D-80B3-2C8B26F25513}"/>
+                <a16:creationId xmlns:a16="http://schemas.microsoft.com/office/drawing/2014/main" id="{BC6C216F-833D-4A33-BABA-524F84E76D0F}"/>
               </a:ext>
             </a:extLst>
           </p:cNvPr>
@@ -10526,7 +10499,7 @@
           <p:cNvPr id="6" name="Text 3">
             <a:extLst xmlns:a="http://schemas.openxmlformats.org/drawingml/2006/main">
               <a:ext uri="{FF2B5EF4-FFF2-40B4-BE49-F238E27FC236}">
-                <a16:creationId xmlns:a16="http://schemas.microsoft.com/office/drawing/2014/main" id="{49953354-42CB-4B9D-899F-3F110106C381}"/>
+                <a16:creationId xmlns:a16="http://schemas.microsoft.com/office/drawing/2014/main" id="{AD6596F7-3CE9-4B61-B340-8C257FEE2B1D}"/>
               </a:ext>
             </a:extLst>
           </p:cNvPr>
@@ -10623,7 +10596,7 @@
           <p:cNvPr id="7" name="Text 4">
             <a:extLst xmlns:a="http://schemas.openxmlformats.org/drawingml/2006/main">
               <a:ext uri="{FF2B5EF4-FFF2-40B4-BE49-F238E27FC236}">
-                <a16:creationId xmlns:a16="http://schemas.microsoft.com/office/drawing/2014/main" id="{9B1454FA-092D-4BAC-965B-E3B5F01FF5B4}"/>
+                <a16:creationId xmlns:a16="http://schemas.microsoft.com/office/drawing/2014/main" id="{CE1C4FAE-791D-4D43-BFFA-A9F154792A5F}"/>
               </a:ext>
             </a:extLst>
           </p:cNvPr>
@@ -10720,7 +10693,7 @@
           <p:cNvPr id="25" name="Slide Number Placeholder 0">
             <a:extLst xmlns:a="http://schemas.openxmlformats.org/drawingml/2006/main">
               <a:ext uri="{FF2B5EF4-FFF2-40B4-BE49-F238E27FC236}">
-                <a16:creationId xmlns:a16="http://schemas.microsoft.com/office/drawing/2014/main" id="{A02B57C1-39D0-46A2-B34A-AB2E0EF54755}"/>
+                <a16:creationId xmlns:a16="http://schemas.microsoft.com/office/drawing/2014/main" id="{828E6D68-C550-4B29-9C15-9E88A8B6AB4F}"/>
               </a:ext>
             </a:extLst>
           </p:cNvPr>
@@ -10767,7 +10740,7 @@
     </p:spTree>
     <p:extLst>
       <p:ext uri="{BB962C8B-B14F-4D97-AF65-F5344CB8AC3E}">
-        <p14:creationId xmlns:p14="http://schemas.microsoft.com/office/powerpoint/2010/main" val="682772279"/>
+        <p14:creationId xmlns:p14="http://schemas.microsoft.com/office/powerpoint/2010/main" val="626159613"/>
       </p:ext>
     </p:extLst>
   </p:cSld>
@@ -10791,7 +10764,7 @@
           <p:cNvPr id="2" name="Text 0">
             <a:extLst xmlns:a="http://schemas.openxmlformats.org/drawingml/2006/main">
               <a:ext uri="{FF2B5EF4-FFF2-40B4-BE49-F238E27FC236}">
-                <a16:creationId xmlns:a16="http://schemas.microsoft.com/office/drawing/2014/main" id="{39955151-F27B-402C-8611-1364E8EEABD9}"/>
+                <a16:creationId xmlns:a16="http://schemas.microsoft.com/office/drawing/2014/main" id="{C8A9A645-CC2F-45D5-BC83-C1C1A5454F4F}"/>
               </a:ext>
             </a:extLst>
           </p:cNvPr>
@@ -10836,7 +10809,7 @@
           <p:cNvPr id="4" name="Text 1">
             <a:extLst xmlns:a="http://schemas.openxmlformats.org/drawingml/2006/main">
               <a:ext uri="{FF2B5EF4-FFF2-40B4-BE49-F238E27FC236}">
-                <a16:creationId xmlns:a16="http://schemas.microsoft.com/office/drawing/2014/main" id="{EF56768B-34BF-4FE6-802A-82ABA4AAB5AE}"/>
+                <a16:creationId xmlns:a16="http://schemas.microsoft.com/office/drawing/2014/main" id="{5371CB78-045C-4651-A7CE-EDC1DE825CD4}"/>
               </a:ext>
             </a:extLst>
           </p:cNvPr>
@@ -10890,7 +10863,7 @@
           <p:cNvPr id="5" name="Shape 2">
             <a:extLst xmlns:a="http://schemas.openxmlformats.org/drawingml/2006/main">
               <a:ext uri="{FF2B5EF4-FFF2-40B4-BE49-F238E27FC236}">
-                <a16:creationId xmlns:a16="http://schemas.microsoft.com/office/drawing/2014/main" id="{F3CF0A6C-9D58-40D3-B13B-536E38B83AB5}"/>
+                <a16:creationId xmlns:a16="http://schemas.microsoft.com/office/drawing/2014/main" id="{0F54141D-C865-4AF9-9339-AAD1E3942227}"/>
               </a:ext>
             </a:extLst>
           </p:cNvPr>
@@ -10922,7 +10895,7 @@
           <p:cNvPr id="6" name="Text 3">
             <a:extLst xmlns:a="http://schemas.openxmlformats.org/drawingml/2006/main">
               <a:ext uri="{FF2B5EF4-FFF2-40B4-BE49-F238E27FC236}">
-                <a16:creationId xmlns:a16="http://schemas.microsoft.com/office/drawing/2014/main" id="{3D8DF253-14D0-4489-9680-CFF652FD0AC6}"/>
+                <a16:creationId xmlns:a16="http://schemas.microsoft.com/office/drawing/2014/main" id="{C09503D8-8D01-47D8-BE90-7FFD41543312}"/>
               </a:ext>
             </a:extLst>
           </p:cNvPr>
@@ -10976,7 +10949,7 @@
           <p:cNvPr id="7" name="Shape 4">
             <a:extLst xmlns:a="http://schemas.openxmlformats.org/drawingml/2006/main">
               <a:ext uri="{FF2B5EF4-FFF2-40B4-BE49-F238E27FC236}">
-                <a16:creationId xmlns:a16="http://schemas.microsoft.com/office/drawing/2014/main" id="{D9197C65-4B0B-48F5-9527-8D6B163306BA}"/>
+                <a16:creationId xmlns:a16="http://schemas.microsoft.com/office/drawing/2014/main" id="{F01B5CCA-ADC5-45C1-8207-CAB0C83A8052}"/>
               </a:ext>
             </a:extLst>
           </p:cNvPr>
@@ -11008,7 +10981,7 @@
           <p:cNvPr id="8" name="Text 5">
             <a:extLst xmlns:a="http://schemas.openxmlformats.org/drawingml/2006/main">
               <a:ext uri="{FF2B5EF4-FFF2-40B4-BE49-F238E27FC236}">
-                <a16:creationId xmlns:a16="http://schemas.microsoft.com/office/drawing/2014/main" id="{54CB0387-2D27-4F29-B9EC-F6F2EAA15148}"/>
+                <a16:creationId xmlns:a16="http://schemas.microsoft.com/office/drawing/2014/main" id="{3864F19D-04BB-426F-844F-D0BAAC1A4700}"/>
               </a:ext>
             </a:extLst>
           </p:cNvPr>
@@ -11062,7 +11035,7 @@
           <p:cNvPr id="9" name="Shape 6">
             <a:extLst xmlns:a="http://schemas.openxmlformats.org/drawingml/2006/main">
               <a:ext uri="{FF2B5EF4-FFF2-40B4-BE49-F238E27FC236}">
-                <a16:creationId xmlns:a16="http://schemas.microsoft.com/office/drawing/2014/main" id="{37AE1F44-4773-4782-B9AC-AC919CEC3757}"/>
+                <a16:creationId xmlns:a16="http://schemas.microsoft.com/office/drawing/2014/main" id="{DD373C10-D0F1-4C3E-BB51-7C6704A2753B}"/>
               </a:ext>
             </a:extLst>
           </p:cNvPr>
@@ -11094,7 +11067,7 @@
           <p:cNvPr id="10" name="Text 7">
             <a:extLst xmlns:a="http://schemas.openxmlformats.org/drawingml/2006/main">
               <a:ext uri="{FF2B5EF4-FFF2-40B4-BE49-F238E27FC236}">
-                <a16:creationId xmlns:a16="http://schemas.microsoft.com/office/drawing/2014/main" id="{1DB47DE5-A060-4FDC-9064-D5F6D633AF36}"/>
+                <a16:creationId xmlns:a16="http://schemas.microsoft.com/office/drawing/2014/main" id="{27F8139D-E402-47D4-AC17-27504D7E94C5}"/>
               </a:ext>
             </a:extLst>
           </p:cNvPr>
@@ -11148,7 +11121,7 @@
           <p:cNvPr id="11" name="Shape 8">
             <a:extLst xmlns:a="http://schemas.openxmlformats.org/drawingml/2006/main">
               <a:ext uri="{FF2B5EF4-FFF2-40B4-BE49-F238E27FC236}">
-                <a16:creationId xmlns:a16="http://schemas.microsoft.com/office/drawing/2014/main" id="{80644B76-485B-43DA-83CC-75560993FEC7}"/>
+                <a16:creationId xmlns:a16="http://schemas.microsoft.com/office/drawing/2014/main" id="{40B27975-3ED8-4233-8E16-C55C8F39104C}"/>
               </a:ext>
             </a:extLst>
           </p:cNvPr>
@@ -11180,7 +11153,7 @@
           <p:cNvPr id="12" name="Text 9">
             <a:extLst xmlns:a="http://schemas.openxmlformats.org/drawingml/2006/main">
               <a:ext uri="{FF2B5EF4-FFF2-40B4-BE49-F238E27FC236}">
-                <a16:creationId xmlns:a16="http://schemas.microsoft.com/office/drawing/2014/main" id="{F01DC7E6-AF35-49E5-89A1-9F49D29FD69E}"/>
+                <a16:creationId xmlns:a16="http://schemas.microsoft.com/office/drawing/2014/main" id="{05720538-E87B-4C43-B26D-DA5DCBBF057F}"/>
               </a:ext>
             </a:extLst>
           </p:cNvPr>
@@ -11234,7 +11207,7 @@
           <p:cNvPr id="13" name="Shape 10">
             <a:extLst xmlns:a="http://schemas.openxmlformats.org/drawingml/2006/main">
               <a:ext uri="{FF2B5EF4-FFF2-40B4-BE49-F238E27FC236}">
-                <a16:creationId xmlns:a16="http://schemas.microsoft.com/office/drawing/2014/main" id="{602D2832-1986-4EE4-B43A-4038527E5CE2}"/>
+                <a16:creationId xmlns:a16="http://schemas.microsoft.com/office/drawing/2014/main" id="{BC71037B-DD06-4004-920A-7EDD92E07F0F}"/>
               </a:ext>
             </a:extLst>
           </p:cNvPr>
@@ -11266,7 +11239,7 @@
           <p:cNvPr id="14" name="Text 11">
             <a:extLst xmlns:a="http://schemas.openxmlformats.org/drawingml/2006/main">
               <a:ext uri="{FF2B5EF4-FFF2-40B4-BE49-F238E27FC236}">
-                <a16:creationId xmlns:a16="http://schemas.microsoft.com/office/drawing/2014/main" id="{77138FF0-7D55-4EE6-AF37-32E788FD15F3}"/>
+                <a16:creationId xmlns:a16="http://schemas.microsoft.com/office/drawing/2014/main" id="{0F08CC21-CB0B-4B62-83C7-212358F6FE49}"/>
               </a:ext>
             </a:extLst>
           </p:cNvPr>
@@ -11320,7 +11293,7 @@
           <p:cNvPr id="15" name="Shape 12">
             <a:extLst xmlns:a="http://schemas.openxmlformats.org/drawingml/2006/main">
               <a:ext uri="{FF2B5EF4-FFF2-40B4-BE49-F238E27FC236}">
-                <a16:creationId xmlns:a16="http://schemas.microsoft.com/office/drawing/2014/main" id="{23F091F9-B8EB-41EB-B2C2-D7C93417A406}"/>
+                <a16:creationId xmlns:a16="http://schemas.microsoft.com/office/drawing/2014/main" id="{56ADB605-EC3E-46D3-918B-2D3E6225D1D1}"/>
               </a:ext>
             </a:extLst>
           </p:cNvPr>
@@ -11352,7 +11325,7 @@
           <p:cNvPr id="16" name="Text 13">
             <a:extLst xmlns:a="http://schemas.openxmlformats.org/drawingml/2006/main">
               <a:ext uri="{FF2B5EF4-FFF2-40B4-BE49-F238E27FC236}">
-                <a16:creationId xmlns:a16="http://schemas.microsoft.com/office/drawing/2014/main" id="{CBF7B041-3263-4784-A8F0-3F118E222420}"/>
+                <a16:creationId xmlns:a16="http://schemas.microsoft.com/office/drawing/2014/main" id="{8F0D99F1-EEFA-4E90-BC8D-26961E27B5B9}"/>
               </a:ext>
             </a:extLst>
           </p:cNvPr>
@@ -11395,7 +11368,7 @@
           <p:cNvPr id="17" name="Text 14">
             <a:extLst xmlns:a="http://schemas.openxmlformats.org/drawingml/2006/main">
               <a:ext uri="{FF2B5EF4-FFF2-40B4-BE49-F238E27FC236}">
-                <a16:creationId xmlns:a16="http://schemas.microsoft.com/office/drawing/2014/main" id="{5FF82AC2-1044-494A-B60E-08334CAE7C9A}"/>
+                <a16:creationId xmlns:a16="http://schemas.microsoft.com/office/drawing/2014/main" id="{16EAC3E0-A87B-4268-89AE-C7ACA0CA708F}"/>
               </a:ext>
             </a:extLst>
           </p:cNvPr>
@@ -11466,7 +11439,7 @@
           <p:cNvPr id="18" name="Text 15">
             <a:extLst xmlns:a="http://schemas.openxmlformats.org/drawingml/2006/main">
               <a:ext uri="{FF2B5EF4-FFF2-40B4-BE49-F238E27FC236}">
-                <a16:creationId xmlns:a16="http://schemas.microsoft.com/office/drawing/2014/main" id="{E65770A2-C182-497B-80BF-8D97A77A1B49}"/>
+                <a16:creationId xmlns:a16="http://schemas.microsoft.com/office/drawing/2014/main" id="{9DDAB71B-AB5D-432C-99E0-C782A5867C41}"/>
               </a:ext>
             </a:extLst>
           </p:cNvPr>
@@ -11607,7 +11580,7 @@
           <p:cNvPr id="25" name="Slide Number Placeholder 0">
             <a:extLst xmlns:a="http://schemas.openxmlformats.org/drawingml/2006/main">
               <a:ext uri="{FF2B5EF4-FFF2-40B4-BE49-F238E27FC236}">
-                <a16:creationId xmlns:a16="http://schemas.microsoft.com/office/drawing/2014/main" id="{95CA5E7B-28FA-41E3-9D6E-5499DB73B4EE}"/>
+                <a16:creationId xmlns:a16="http://schemas.microsoft.com/office/drawing/2014/main" id="{EB8DBD04-F690-4FB1-A929-8FC2E3442C31}"/>
               </a:ext>
             </a:extLst>
           </p:cNvPr>
@@ -11654,7 +11627,7 @@
     </p:spTree>
     <p:extLst>
       <p:ext uri="{BB962C8B-B14F-4D97-AF65-F5344CB8AC3E}">
-        <p14:creationId xmlns:p14="http://schemas.microsoft.com/office/powerpoint/2010/main" val="1139906247"/>
+        <p14:creationId xmlns:p14="http://schemas.microsoft.com/office/powerpoint/2010/main" val="38787870"/>
       </p:ext>
     </p:extLst>
   </p:cSld>
@@ -11678,7 +11651,7 @@
           <p:cNvPr id="2" name="Text 0">
             <a:extLst xmlns:a="http://schemas.openxmlformats.org/drawingml/2006/main">
               <a:ext uri="{FF2B5EF4-FFF2-40B4-BE49-F238E27FC236}">
-                <a16:creationId xmlns:a16="http://schemas.microsoft.com/office/drawing/2014/main" id="{6D9DAF25-6C26-4CD7-A4A7-866CFAB20933}"/>
+                <a16:creationId xmlns:a16="http://schemas.microsoft.com/office/drawing/2014/main" id="{41D65A6A-50A0-4FB6-8BF8-DEACEA85A18C}"/>
               </a:ext>
             </a:extLst>
           </p:cNvPr>
@@ -11723,7 +11696,7 @@
           <p:cNvPr id="7" name="Table 0">
             <a:extLst xmlns:a="http://schemas.openxmlformats.org/drawingml/2006/main">
               <a:ext uri="{FF2B5EF4-FFF2-40B4-BE49-F238E27FC236}">
-                <a16:creationId xmlns:a16="http://schemas.microsoft.com/office/drawing/2014/main" id="{BDA7ACBD-197B-4855-8152-D5990BE14242}"/>
+                <a16:creationId xmlns:a16="http://schemas.microsoft.com/office/drawing/2014/main" id="{9A1B5FAD-82EA-4472-953C-E26D6833B7EC}"/>
               </a:ext>
             </a:extLst>
           </p:cNvPr>
@@ -12619,7 +12592,7 @@
           <p:cNvPr id="5" name="Text 1">
             <a:extLst xmlns:a="http://schemas.openxmlformats.org/drawingml/2006/main">
               <a:ext uri="{FF2B5EF4-FFF2-40B4-BE49-F238E27FC236}">
-                <a16:creationId xmlns:a16="http://schemas.microsoft.com/office/drawing/2014/main" id="{1AC89D6A-385E-4287-9D6D-B1C3C510AFC6}"/>
+                <a16:creationId xmlns:a16="http://schemas.microsoft.com/office/drawing/2014/main" id="{2559854E-88E4-4137-8F0A-E6E8D32E8DC9}"/>
               </a:ext>
             </a:extLst>
           </p:cNvPr>
@@ -12662,7 +12635,7 @@
           <p:cNvPr id="25" name="Slide Number Placeholder 0">
             <a:extLst xmlns:a="http://schemas.openxmlformats.org/drawingml/2006/main">
               <a:ext uri="{FF2B5EF4-FFF2-40B4-BE49-F238E27FC236}">
-                <a16:creationId xmlns:a16="http://schemas.microsoft.com/office/drawing/2014/main" id="{EC8F5211-3206-45F4-BE2D-9F599836A8A7}"/>
+                <a16:creationId xmlns:a16="http://schemas.microsoft.com/office/drawing/2014/main" id="{D92E696D-0958-436D-ACF0-E261003B1614}"/>
               </a:ext>
             </a:extLst>
           </p:cNvPr>
@@ -12709,7 +12682,7 @@
     </p:spTree>
     <p:extLst>
       <p:ext uri="{BB962C8B-B14F-4D97-AF65-F5344CB8AC3E}">
-        <p14:creationId xmlns:p14="http://schemas.microsoft.com/office/powerpoint/2010/main" val="2001610551"/>
+        <p14:creationId xmlns:p14="http://schemas.microsoft.com/office/powerpoint/2010/main" val="1476568058"/>
       </p:ext>
     </p:extLst>
   </p:cSld>
@@ -12733,7 +12706,7 @@
           <p:cNvPr id="2" name="Text 0">
             <a:extLst xmlns:a="http://schemas.openxmlformats.org/drawingml/2006/main">
               <a:ext uri="{FF2B5EF4-FFF2-40B4-BE49-F238E27FC236}">
-                <a16:creationId xmlns:a16="http://schemas.microsoft.com/office/drawing/2014/main" id="{0FB93591-39B0-48FE-BC37-E3468DA268A7}"/>
+                <a16:creationId xmlns:a16="http://schemas.microsoft.com/office/drawing/2014/main" id="{04AC8065-226A-431A-B934-BD466D7A42DC}"/>
               </a:ext>
             </a:extLst>
           </p:cNvPr>
@@ -12778,7 +12751,7 @@
           <p:cNvPr id="4" name="Text 1">
             <a:extLst xmlns:a="http://schemas.openxmlformats.org/drawingml/2006/main">
               <a:ext uri="{FF2B5EF4-FFF2-40B4-BE49-F238E27FC236}">
-                <a16:creationId xmlns:a16="http://schemas.microsoft.com/office/drawing/2014/main" id="{6E7A262D-9FE3-44A6-B855-2B75EB3C18BD}"/>
+                <a16:creationId xmlns:a16="http://schemas.microsoft.com/office/drawing/2014/main" id="{3217D760-08CF-450F-BB17-E6288733F9AA}"/>
               </a:ext>
             </a:extLst>
           </p:cNvPr>
@@ -12915,7 +12888,7 @@
           <p:cNvPr id="5" name="Text 2">
             <a:extLst xmlns:a="http://schemas.openxmlformats.org/drawingml/2006/main">
               <a:ext uri="{FF2B5EF4-FFF2-40B4-BE49-F238E27FC236}">
-                <a16:creationId xmlns:a16="http://schemas.microsoft.com/office/drawing/2014/main" id="{C00957DD-4666-4C4C-B5FB-E100277EAC8D}"/>
+                <a16:creationId xmlns:a16="http://schemas.microsoft.com/office/drawing/2014/main" id="{FEC2ABB3-6CBB-4480-8D28-12B28E27C16B}"/>
               </a:ext>
             </a:extLst>
           </p:cNvPr>
@@ -13052,7 +13025,7 @@
           <p:cNvPr id="6" name="Text 3">
             <a:extLst xmlns:a="http://schemas.openxmlformats.org/drawingml/2006/main">
               <a:ext uri="{FF2B5EF4-FFF2-40B4-BE49-F238E27FC236}">
-                <a16:creationId xmlns:a16="http://schemas.microsoft.com/office/drawing/2014/main" id="{A629EBB1-9AC6-4FD5-9B63-B4A8464D4D43}"/>
+                <a16:creationId xmlns:a16="http://schemas.microsoft.com/office/drawing/2014/main" id="{84E46F22-5725-427B-94FD-67D5980DDDEC}"/>
               </a:ext>
             </a:extLst>
           </p:cNvPr>
@@ -13189,7 +13162,7 @@
           <p:cNvPr id="25" name="Slide Number Placeholder 0">
             <a:extLst xmlns:a="http://schemas.openxmlformats.org/drawingml/2006/main">
               <a:ext uri="{FF2B5EF4-FFF2-40B4-BE49-F238E27FC236}">
-                <a16:creationId xmlns:a16="http://schemas.microsoft.com/office/drawing/2014/main" id="{6968725A-1AEE-4345-A2E5-2336E7EEE3CA}"/>
+                <a16:creationId xmlns:a16="http://schemas.microsoft.com/office/drawing/2014/main" id="{0AD77860-193A-45BC-9048-207148480729}"/>
               </a:ext>
             </a:extLst>
           </p:cNvPr>
@@ -13236,7 +13209,7 @@
     </p:spTree>
     <p:extLst>
       <p:ext uri="{BB962C8B-B14F-4D97-AF65-F5344CB8AC3E}">
-        <p14:creationId xmlns:p14="http://schemas.microsoft.com/office/powerpoint/2010/main" val="1330334372"/>
+        <p14:creationId xmlns:p14="http://schemas.microsoft.com/office/powerpoint/2010/main" val="1986189672"/>
       </p:ext>
     </p:extLst>
   </p:cSld>
@@ -13260,7 +13233,7 @@
           <p:cNvPr id="2" name="Text 0">
             <a:extLst xmlns:a="http://schemas.openxmlformats.org/drawingml/2006/main">
               <a:ext uri="{FF2B5EF4-FFF2-40B4-BE49-F238E27FC236}">
-                <a16:creationId xmlns:a16="http://schemas.microsoft.com/office/drawing/2014/main" id="{C8D1E6F6-F74A-4653-AEF0-ED1DE882BE12}"/>
+                <a16:creationId xmlns:a16="http://schemas.microsoft.com/office/drawing/2014/main" id="{D34DD12F-A39D-462D-9EFA-C7BC95880E9F}"/>
               </a:ext>
             </a:extLst>
           </p:cNvPr>
@@ -13305,7 +13278,7 @@
           <p:cNvPr id="4" name="Text 1">
             <a:extLst xmlns:a="http://schemas.openxmlformats.org/drawingml/2006/main">
               <a:ext uri="{FF2B5EF4-FFF2-40B4-BE49-F238E27FC236}">
-                <a16:creationId xmlns:a16="http://schemas.microsoft.com/office/drawing/2014/main" id="{9618FA77-30BB-45F7-9A88-02EBF1043EE7}"/>
+                <a16:creationId xmlns:a16="http://schemas.microsoft.com/office/drawing/2014/main" id="{46D74D18-7A80-40D2-B7E6-153196E52929}"/>
               </a:ext>
             </a:extLst>
           </p:cNvPr>
@@ -13359,7 +13332,7 @@
           <p:cNvPr id="5" name="Text 2">
             <a:extLst xmlns:a="http://schemas.openxmlformats.org/drawingml/2006/main">
               <a:ext uri="{FF2B5EF4-FFF2-40B4-BE49-F238E27FC236}">
-                <a16:creationId xmlns:a16="http://schemas.microsoft.com/office/drawing/2014/main" id="{F7ED74CF-9A78-4A38-9C47-A6425A8ED84B}"/>
+                <a16:creationId xmlns:a16="http://schemas.microsoft.com/office/drawing/2014/main" id="{577ABE11-F5D1-4A3C-AC53-F382AE61114C}"/>
               </a:ext>
             </a:extLst>
           </p:cNvPr>
@@ -13424,7 +13397,7 @@
           <p:cNvPr id="6" name="Text 3">
             <a:extLst xmlns:a="http://schemas.openxmlformats.org/drawingml/2006/main">
               <a:ext uri="{FF2B5EF4-FFF2-40B4-BE49-F238E27FC236}">
-                <a16:creationId xmlns:a16="http://schemas.microsoft.com/office/drawing/2014/main" id="{62025BD5-5241-477D-9596-6911099624D4}"/>
+                <a16:creationId xmlns:a16="http://schemas.microsoft.com/office/drawing/2014/main" id="{D74DAF2A-EC1C-47DF-8C4D-A43E76028B9A}"/>
               </a:ext>
             </a:extLst>
           </p:cNvPr>
@@ -13478,7 +13451,7 @@
           <p:cNvPr id="7" name="Text 4">
             <a:extLst xmlns:a="http://schemas.openxmlformats.org/drawingml/2006/main">
               <a:ext uri="{FF2B5EF4-FFF2-40B4-BE49-F238E27FC236}">
-                <a16:creationId xmlns:a16="http://schemas.microsoft.com/office/drawing/2014/main" id="{864D1163-4C49-4E69-B220-63A616B0089F}"/>
+                <a16:creationId xmlns:a16="http://schemas.microsoft.com/office/drawing/2014/main" id="{12275D54-BAA8-4B4F-B8C9-8167AF0EB83B}"/>
               </a:ext>
             </a:extLst>
           </p:cNvPr>
@@ -13543,7 +13516,7 @@
           <p:cNvPr id="8" name="Text 5">
             <a:extLst xmlns:a="http://schemas.openxmlformats.org/drawingml/2006/main">
               <a:ext uri="{FF2B5EF4-FFF2-40B4-BE49-F238E27FC236}">
-                <a16:creationId xmlns:a16="http://schemas.microsoft.com/office/drawing/2014/main" id="{C02A1624-951E-4955-82D9-E1244F03459C}"/>
+                <a16:creationId xmlns:a16="http://schemas.microsoft.com/office/drawing/2014/main" id="{78F8CA09-EF4D-4DE3-B767-79D77BFA97D8}"/>
               </a:ext>
             </a:extLst>
           </p:cNvPr>
@@ -13597,7 +13570,7 @@
           <p:cNvPr id="9" name="Text 6">
             <a:extLst xmlns:a="http://schemas.openxmlformats.org/drawingml/2006/main">
               <a:ext uri="{FF2B5EF4-FFF2-40B4-BE49-F238E27FC236}">
-                <a16:creationId xmlns:a16="http://schemas.microsoft.com/office/drawing/2014/main" id="{74C54662-3204-45DB-96FF-331980440159}"/>
+                <a16:creationId xmlns:a16="http://schemas.microsoft.com/office/drawing/2014/main" id="{6282B439-AB12-4229-ACFB-43D9C7682C83}"/>
               </a:ext>
             </a:extLst>
           </p:cNvPr>
@@ -13662,7 +13635,7 @@
           <p:cNvPr id="25" name="Slide Number Placeholder 0">
             <a:extLst xmlns:a="http://schemas.openxmlformats.org/drawingml/2006/main">
               <a:ext uri="{FF2B5EF4-FFF2-40B4-BE49-F238E27FC236}">
-                <a16:creationId xmlns:a16="http://schemas.microsoft.com/office/drawing/2014/main" id="{1ABF4243-5ECB-4F8C-9645-FFDA3A22D27D}"/>
+                <a16:creationId xmlns:a16="http://schemas.microsoft.com/office/drawing/2014/main" id="{EF2A7248-0CEE-469D-A87A-9508E208EF78}"/>
               </a:ext>
             </a:extLst>
           </p:cNvPr>
@@ -13709,7 +13682,7 @@
     </p:spTree>
     <p:extLst>
       <p:ext uri="{BB962C8B-B14F-4D97-AF65-F5344CB8AC3E}">
-        <p14:creationId xmlns:p14="http://schemas.microsoft.com/office/powerpoint/2010/main" val="1547665457"/>
+        <p14:creationId xmlns:p14="http://schemas.microsoft.com/office/powerpoint/2010/main" val="330588334"/>
       </p:ext>
     </p:extLst>
   </p:cSld>
@@ -13733,7 +13706,7 @@
           <p:cNvPr id="2" name="Text 0">
             <a:extLst xmlns:a="http://schemas.openxmlformats.org/drawingml/2006/main">
               <a:ext uri="{FF2B5EF4-FFF2-40B4-BE49-F238E27FC236}">
-                <a16:creationId xmlns:a16="http://schemas.microsoft.com/office/drawing/2014/main" id="{57788B26-FE7A-4C0E-82F3-53369C079380}"/>
+                <a16:creationId xmlns:a16="http://schemas.microsoft.com/office/drawing/2014/main" id="{80FABB69-4995-4893-9FC5-AD50284813EF}"/>
               </a:ext>
             </a:extLst>
           </p:cNvPr>
@@ -13778,7 +13751,7 @@
           <p:cNvPr id="4" name="Text 1">
             <a:extLst xmlns:a="http://schemas.openxmlformats.org/drawingml/2006/main">
               <a:ext uri="{FF2B5EF4-FFF2-40B4-BE49-F238E27FC236}">
-                <a16:creationId xmlns:a16="http://schemas.microsoft.com/office/drawing/2014/main" id="{ED9CA8BB-FEB7-441B-91F2-68AFC0CE93B3}"/>
+                <a16:creationId xmlns:a16="http://schemas.microsoft.com/office/drawing/2014/main" id="{7FF6BB84-04C2-4AC3-A4D6-A88423EC87FF}"/>
               </a:ext>
             </a:extLst>
           </p:cNvPr>
@@ -13875,7 +13848,7 @@
           <p:cNvPr id="5" name="Text 2">
             <a:extLst xmlns:a="http://schemas.openxmlformats.org/drawingml/2006/main">
               <a:ext uri="{FF2B5EF4-FFF2-40B4-BE49-F238E27FC236}">
-                <a16:creationId xmlns:a16="http://schemas.microsoft.com/office/drawing/2014/main" id="{DE16F264-7314-4A40-9C30-775E072E5CE7}"/>
+                <a16:creationId xmlns:a16="http://schemas.microsoft.com/office/drawing/2014/main" id="{E02B1CEF-BEEF-4AFD-862A-7869E6C2441A}"/>
               </a:ext>
             </a:extLst>
           </p:cNvPr>
@@ -13972,7 +13945,7 @@
           <p:cNvPr id="10" name="Table 0">
             <a:extLst xmlns:a="http://schemas.openxmlformats.org/drawingml/2006/main">
               <a:ext uri="{FF2B5EF4-FFF2-40B4-BE49-F238E27FC236}">
-                <a16:creationId xmlns:a16="http://schemas.microsoft.com/office/drawing/2014/main" id="{FF13E6BD-E3BB-41E2-B4F6-F6D968526000}"/>
+                <a16:creationId xmlns:a16="http://schemas.microsoft.com/office/drawing/2014/main" id="{7F8215EB-1567-4D76-AC21-22CDF933AACC}"/>
               </a:ext>
             </a:extLst>
           </p:cNvPr>
@@ -14430,7 +14403,7 @@
           <p:cNvPr id="25" name="Slide Number Placeholder 0">
             <a:extLst xmlns:a="http://schemas.openxmlformats.org/drawingml/2006/main">
               <a:ext uri="{FF2B5EF4-FFF2-40B4-BE49-F238E27FC236}">
-                <a16:creationId xmlns:a16="http://schemas.microsoft.com/office/drawing/2014/main" id="{D6C16C76-AE44-49AE-B524-0B54353F0063}"/>
+                <a16:creationId xmlns:a16="http://schemas.microsoft.com/office/drawing/2014/main" id="{622F9805-9281-42EB-A296-8B28054798C7}"/>
               </a:ext>
             </a:extLst>
           </p:cNvPr>
@@ -14479,7 +14452,7 @@
           <p:cNvPr id="26" name="Cause box">
             <a:extLst xmlns:a="http://schemas.openxmlformats.org/drawingml/2006/main">
               <a:ext uri="{FF2B5EF4-FFF2-40B4-BE49-F238E27FC236}">
-                <a16:creationId xmlns:a16="http://schemas.microsoft.com/office/drawing/2014/main" id="{E4B7B703-C06C-4ED7-99A7-FEF935209963}"/>
+                <a16:creationId xmlns:a16="http://schemas.microsoft.com/office/drawing/2014/main" id="{532E5539-BC99-4502-9585-07D722616D5D}"/>
               </a:ext>
             </a:extLst>
           </p:cNvPr>
@@ -14555,7 +14528,7 @@
           <p:cNvPr id="27" name="Detection line">
             <a:extLst xmlns:a="http://schemas.openxmlformats.org/drawingml/2006/main">
               <a:ext uri="{FF2B5EF4-FFF2-40B4-BE49-F238E27FC236}">
-                <a16:creationId xmlns:a16="http://schemas.microsoft.com/office/drawing/2014/main" id="{175530EF-759D-48EE-BFC8-43A6853BF64A}"/>
+                <a16:creationId xmlns:a16="http://schemas.microsoft.com/office/drawing/2014/main" id="{675FB293-92B2-4665-98DA-70D2A876529B}"/>
               </a:ext>
             </a:extLst>
           </p:cNvPr>
@@ -14614,7 +14587,7 @@
     </p:spTree>
     <p:extLst>
       <p:ext uri="{BB962C8B-B14F-4D97-AF65-F5344CB8AC3E}">
-        <p14:creationId xmlns:p14="http://schemas.microsoft.com/office/powerpoint/2010/main" val="969507307"/>
+        <p14:creationId xmlns:p14="http://schemas.microsoft.com/office/powerpoint/2010/main" val="818503788"/>
       </p:ext>
     </p:extLst>
   </p:cSld>

</xml_diff>